<commit_message>
Add virtual-machine walk and in-browser TLB measurement
- Hardware switch "Inside a virtual machine": nested paging, shown as a grid
  of up to 24 numbered reads (4 host reads before each guest level, plus 4
  for the final page)
- "Measure this computer": a pointer chase in the viewer's browser, packed
  versus spread over pages; the gap is the real page-walk cost
- Review 3 deck: new VM and measurement slides, VM bar on the reads chart

Co-Authored-By: Claude Opus 5.5 <noreply@anthropic.com>
</commit_message>
<xml_diff>
--- a/deliverables/review3_changes.pptx
+++ b/deliverables/review3_changes.pptx
@@ -17,9 +17,11 @@
     <p:sldId id="265" r:id="rId11"/>
     <p:sldId id="266" r:id="rId12"/>
     <p:sldId id="267" r:id="rId13"/>
+    <p:sldId id="268" r:id="rId14"/>
+    <p:sldId id="269" r:id="rId15"/>
   </p:sldIdLst>
   <p:notesMasterIdLst>
-    <p:notesMasterId r:id="rId14"/>
+    <p:notesMasterId r:id="rId16"/>
   </p:notesMasterIdLst>
   <p:sldSz cx="12192000" cy="6858000"/>
   <p:notesSz cx="6858000" cy="12192000"/>
@@ -118,19 +120,19 @@
   <p:extLst>
     <p:ext uri="{521415D9-36F7-43E2-AB2F-B90AF26B5E84}">
       <p14:sectionLst xmlns:p14="http://schemas.microsoft.com/office/powerpoint/2010/main">
-        <p14:section name="Opening" id="{f82eaf78-b95d-96ff-432e-a4fc1e4d71f4}">
+        <p14:section name="Opening" id="{05b8fad7-a341-303e-058e-6843178fd647}">
           <p14:sldIdLst>
             <p14:sldId id="256"/>
           </p14:sldIdLst>
         </p14:section>
-        <p14:section name="What we added" id="{cd6be5d1-ab66-ee0d-d153-06ec52517aed}">
+        <p14:section name="What we added" id="{580237b9-4be9-0c85-c185-5d945580eb96}">
           <p14:sldIdLst>
             <p14:sldId id="257"/>
             <p14:sldId id="258"/>
             <p14:sldId id="259"/>
           </p14:sldIdLst>
         </p14:section>
-        <p14:section name="The demo" id="{3cb1c43a-0ae7-9be8-f760-ddf6ef4ee5c3}">
+        <p14:section name="The demo" id="{0d61c4a9-7b54-7efd-3b03-ed089c7d9ee2}">
           <p14:sldIdLst>
             <p14:sldId id="260"/>
             <p14:sldId id="261"/>
@@ -138,12 +140,14 @@
             <p14:sldId id="263"/>
             <p14:sldId id="264"/>
             <p14:sldId id="265"/>
+            <p14:sldId id="266"/>
+            <p14:sldId id="267"/>
           </p14:sldIdLst>
         </p14:section>
-        <p14:section name="Changes and next" id="{da23c5f3-cbdc-9c3e-021e-eca1a1cc3bd2}">
+        <p14:section name="Changes and next" id="{1cff947c-c767-cd7d-cc4f-f3be857eabea}">
           <p14:sldIdLst>
-            <p14:sldId id="266"/>
-            <p14:sldId id="267"/>
+            <p14:sldId id="268"/>
+            <p14:sldId id="269"/>
           </p14:sldIdLst>
         </p14:section>
       </p14:sectionLst>
@@ -243,9 +247,9 @@
           </c:dLbls>
           <c:cat>
             <c:multiLvlStrRef>
-              <c:f>Sheet1!$A$2:$A$5</c:f>
+              <c:f>Sheet1!$A$2:$A$6</c:f>
               <c:multiLvlStrCache>
-                <c:ptCount val="4"/>
+                <c:ptCount val="5"/>
                 <c:lvl>
                   <c:pt idx="0">
                     <c:v>Both on</c:v>
@@ -259,16 +263,19 @@
                   <c:pt idx="3">
                     <c:v>Both off</c:v>
                   </c:pt>
+                  <c:pt idx="4">
+                    <c:v>Inside a VM</c:v>
+                  </c:pt>
                 </c:lvl>
               </c:multiLvlStrCache>
             </c:multiLvlStrRef>
           </c:cat>
           <c:val>
             <c:numRef>
-              <c:f>Sheet1!$B$2:$B$5</c:f>
+              <c:f>Sheet1!$B$2:$B$6</c:f>
               <c:numCache>
                 <c:formatCode>General</c:formatCode>
-                <c:ptCount val="4"/>
+                <c:ptCount val="5"/>
                 <c:pt idx="0">
                   <c:v>201</c:v>
                 </c:pt>
@@ -280,6 +287,9 @@
                 </c:pt>
                 <c:pt idx="3">
                   <c:v>1273</c:v>
+                </c:pt>
+                <c:pt idx="4">
+                  <c:v>1525</c:v>
                 </c:pt>
               </c:numCache>
             </c:numRef>
@@ -902,7 +912,7 @@
           <a:p>
             <a:r>
               <a:rPr lang="en-US" dirty="0"/>
-              <a:t>The demo hides the detail, but it is all there: each entry the CPU read, its address, its 64-bit value and the flag bits that decided the outcome.</a:t>
+              <a:t>The same switches are on the page, so this can be shown live. With the walk cache off, every TLB miss reads all four levels; with large pages off, the buffer needs 4 KB pages and an extra level. Inside a VM, with both caches on, the same work needs 7.6 times the reads.</a:t>
             </a:r>
             <a:endParaRPr lang="en-US" dirty="0"/>
           </a:p>
@@ -990,7 +1000,7 @@
           <a:p>
             <a:r>
               <a:rPr lang="en-US" dirty="0"/>
-              <a:t>Everything runs in plain Python inside Streamlit, so deployment is still just pushing the repository.</a:t>
+              <a:t>This answers 'modelled, not measured'. The page runs a pointer chase in the viewer's browser: the same reads, packed into a few pages or spread one per page. Once the pages outgrow the TLB, every spread read also pays a page walk. Nothing is sent to the server.</a:t>
             </a:r>
             <a:endParaRPr lang="en-US" dirty="0"/>
           </a:p>
@@ -1078,7 +1088,7 @@
           <a:p>
             <a:r>
               <a:rPr lang="en-US" dirty="0"/>
-              <a:t>Run these in order on the live site. Reset first if anything is already on screen.</a:t>
+              <a:t>The demo hides the detail, but it is all there: each entry the CPU read, its address, its 64-bit value and the flag bits that decided the outcome.</a:t>
             </a:r>
             <a:endParaRPr lang="en-US" dirty="0"/>
           </a:p>
@@ -1102,6 +1112,182 @@
             <a:fld id="{F7021451-1387-4CA6-816F-3879F97B5CBC}" type="slidenum">
               <a:rPr lang="en-US"/>
               <a:t>12</a:t>
+            </a:fld>
+            <a:endParaRPr lang="en-US"/>
+          </a:p>
+        </p:txBody>
+      </p:sp>
+    </p:spTree>
+    <p:extLst>
+      <p:ext uri="{BB962C8B-B14F-4D97-AF65-F5344CB8AC3E}">
+        <p14:creationId xmlns:p14="http://schemas.microsoft.com/office/powerpoint/2010/main" val="1024086991"/>
+      </p:ext>
+    </p:extLst>
+  </p:cSld>
+  <p:clrMapOvr>
+    <a:masterClrMapping/>
+  </p:clrMapOvr>
+</p:notes>
+</file>
+
+<file path=ppt/notesSlides/notesSlide13.xml><?xml version="1.0" encoding="utf-8"?>
+<p:notes xmlns:a="http://schemas.openxmlformats.org/drawingml/2006/main" xmlns:r="http://schemas.openxmlformats.org/officeDocument/2006/relationships" xmlns:p="http://schemas.openxmlformats.org/presentationml/2006/main">
+  <p:cSld>
+    <p:spTree>
+      <p:nvGrpSpPr>
+        <p:cNvPr id="1" name=""/>
+        <p:cNvGrpSpPr/>
+        <p:nvPr/>
+      </p:nvGrpSpPr>
+      <p:grpSpPr>
+        <a:xfrm>
+          <a:off x="0" y="0"/>
+          <a:ext cx="0" cy="0"/>
+          <a:chOff x="0" y="0"/>
+          <a:chExt cx="0" cy="0"/>
+        </a:xfrm>
+      </p:grpSpPr>
+      <p:sp>
+        <p:nvSpPr>
+          <p:cNvPr id="2" name="Slide Image Placeholder 1"/>
+          <p:cNvSpPr>
+            <a:spLocks noGrp="1" noRot="1" noChangeAspect="1"/>
+          </p:cNvSpPr>
+          <p:nvPr>
+            <p:ph type="sldImg"/>
+          </p:nvPr>
+        </p:nvSpPr>
+        <p:spPr/>
+      </p:sp>
+      <p:sp>
+        <p:nvSpPr>
+          <p:cNvPr id="3" name="Notes Placeholder 2"/>
+          <p:cNvSpPr>
+            <a:spLocks noGrp="1"/>
+          </p:cNvSpPr>
+          <p:nvPr>
+            <p:ph type="body" idx="1"/>
+          </p:nvPr>
+        </p:nvSpPr>
+        <p:spPr/>
+        <p:txBody>
+          <a:bodyPr/>
+          <a:lstStyle/>
+          <a:p>
+            <a:r>
+              <a:rPr lang="en-US" dirty="0"/>
+              <a:t>Everything runs in plain Python inside Streamlit, so deployment is still just pushing the repository.</a:t>
+            </a:r>
+            <a:endParaRPr lang="en-US" dirty="0"/>
+          </a:p>
+        </p:txBody>
+      </p:sp>
+      <p:sp>
+        <p:nvSpPr>
+          <p:cNvPr id="4" name="Slide Number Placeholder 3"/>
+          <p:cNvSpPr>
+            <a:spLocks noGrp="1"/>
+          </p:cNvSpPr>
+          <p:nvPr>
+            <p:ph type="sldNum" sz="quarter" idx="10"/>
+          </p:nvPr>
+        </p:nvSpPr>
+        <p:spPr/>
+        <p:txBody>
+          <a:bodyPr/>
+          <a:lstStyle/>
+          <a:p>
+            <a:fld id="{F7021451-1387-4CA6-816F-3879F97B5CBC}" type="slidenum">
+              <a:rPr lang="en-US"/>
+              <a:t>13</a:t>
+            </a:fld>
+            <a:endParaRPr lang="en-US"/>
+          </a:p>
+        </p:txBody>
+      </p:sp>
+    </p:spTree>
+    <p:extLst>
+      <p:ext uri="{BB962C8B-B14F-4D97-AF65-F5344CB8AC3E}">
+        <p14:creationId xmlns:p14="http://schemas.microsoft.com/office/powerpoint/2010/main" val="1024086991"/>
+      </p:ext>
+    </p:extLst>
+  </p:cSld>
+  <p:clrMapOvr>
+    <a:masterClrMapping/>
+  </p:clrMapOvr>
+</p:notes>
+</file>
+
+<file path=ppt/notesSlides/notesSlide14.xml><?xml version="1.0" encoding="utf-8"?>
+<p:notes xmlns:a="http://schemas.openxmlformats.org/drawingml/2006/main" xmlns:r="http://schemas.openxmlformats.org/officeDocument/2006/relationships" xmlns:p="http://schemas.openxmlformats.org/presentationml/2006/main">
+  <p:cSld>
+    <p:spTree>
+      <p:nvGrpSpPr>
+        <p:cNvPr id="1" name=""/>
+        <p:cNvGrpSpPr/>
+        <p:nvPr/>
+      </p:nvGrpSpPr>
+      <p:grpSpPr>
+        <a:xfrm>
+          <a:off x="0" y="0"/>
+          <a:ext cx="0" cy="0"/>
+          <a:chOff x="0" y="0"/>
+          <a:chExt cx="0" cy="0"/>
+        </a:xfrm>
+      </p:grpSpPr>
+      <p:sp>
+        <p:nvSpPr>
+          <p:cNvPr id="2" name="Slide Image Placeholder 1"/>
+          <p:cNvSpPr>
+            <a:spLocks noGrp="1" noRot="1" noChangeAspect="1"/>
+          </p:cNvSpPr>
+          <p:nvPr>
+            <p:ph type="sldImg"/>
+          </p:nvPr>
+        </p:nvSpPr>
+        <p:spPr/>
+      </p:sp>
+      <p:sp>
+        <p:nvSpPr>
+          <p:cNvPr id="3" name="Notes Placeholder 2"/>
+          <p:cNvSpPr>
+            <a:spLocks noGrp="1"/>
+          </p:cNvSpPr>
+          <p:nvPr>
+            <p:ph type="body" idx="1"/>
+          </p:nvPr>
+        </p:nvSpPr>
+        <p:spPr/>
+        <p:txBody>
+          <a:bodyPr/>
+          <a:lstStyle/>
+          <a:p>
+            <a:r>
+              <a:rPr lang="en-US" dirty="0"/>
+              <a:t>Run these in order on the live site. Reset first if anything is already on screen.</a:t>
+            </a:r>
+            <a:endParaRPr lang="en-US" dirty="0"/>
+          </a:p>
+        </p:txBody>
+      </p:sp>
+      <p:sp>
+        <p:nvSpPr>
+          <p:cNvPr id="4" name="Slide Number Placeholder 3"/>
+          <p:cNvSpPr>
+            <a:spLocks noGrp="1"/>
+          </p:cNvSpPr>
+          <p:nvPr>
+            <p:ph type="sldNum" sz="quarter" idx="10"/>
+          </p:nvPr>
+        </p:nvSpPr>
+        <p:spPr/>
+        <p:txBody>
+          <a:bodyPr/>
+          <a:lstStyle/>
+          <a:p>
+            <a:fld id="{F7021451-1387-4CA6-816F-3879F97B5CBC}" type="slidenum">
+              <a:rPr lang="en-US"/>
+              <a:t>14</a:t>
             </a:fld>
             <a:endParaRPr lang="en-US"/>
           </a:p>
@@ -1694,7 +1880,7 @@
           <a:p>
             <a:r>
               <a:rPr lang="en-US" dirty="0"/>
-              <a:t>The tree grows as you click. Orange is the latest walk, blue the levels the walk cache skipped. Only tables with a used entry exist, which is why a four-level tree beats a flat table.</a:t>
+              <a:t>Turn on 'Inside a virtual machine' in Hardware. Windows is now a guest: every table address its walk uses is a guest-physical address, which the host must translate with its own four-level walk first. Four guest levels times five reads, plus four for the final page, gives 24.</a:t>
             </a:r>
             <a:endParaRPr lang="en-US" dirty="0"/>
           </a:p>
@@ -1782,7 +1968,7 @@
           <a:p>
             <a:r>
               <a:rPr lang="en-US" dirty="0"/>
-              <a:t>The same switches are on the page, so this can be shown live. With the walk cache off, every TLB miss reads all four levels; with large pages off, the buffer needs 4 KB pages and an extra level.</a:t>
+              <a:t>The tree grows as you click. Orange is the latest walk, blue the levels the walk cache skipped. Only tables with a used entry exist, which is why a four-level tree beats a flat table.</a:t>
             </a:r>
             <a:endParaRPr lang="en-US" dirty="0"/>
           </a:p>
@@ -2906,7 +3092,7 @@
                   <a:schemeClr val="accent1"/>
                 </a:solidFill>
               </a:rPr>
-              <a:t>FOR QUESTIONS</a:t>
+              <a:t>HARDWARE SWITCHES</a:t>
             </a:r>
             <a:endParaRPr lang="en-US" sz="1300" dirty="0"/>
           </a:p>
@@ -2947,15 +3133,247 @@
                 <a:ea typeface="Cambria" pitchFamily="34" charset="-122"/>
                 <a:cs typeface="Cambria" pitchFamily="34" charset="-120"/>
               </a:rPr>
-              <a:t>The real entry bits are one click away</a:t>
+              <a:t>Caches cut page-table reads; a VM multiplies them</a:t>
             </a:r>
             <a:endParaRPr lang="en-US" sz="3200" dirty="0"/>
           </a:p>
         </p:txBody>
       </p:sp>
+      <p:graphicFrame>
+        <p:nvGraphicFramePr>
+          <p:cNvPr id="4" name="Reads chart" descr=""/>
+          <p:cNvGraphicFramePr/>
+          <p:nvPr/>
+        </p:nvGraphicFramePr>
+        <p:xfrm>
+          <a:off x="548640" y="1645920"/>
+          <a:ext cx="7863840" cy="4480560"/>
+        </p:xfrm>
+        <a:graphic xmlns:a="http://schemas.openxmlformats.org/drawingml/2006/main">
+          <a:graphicData uri="http://schemas.openxmlformats.org/drawingml/2006/chart">
+            <c:chart xmlns:c="http://schemas.openxmlformats.org/drawingml/2006/chart" r:id="rId1"/>
+          </a:graphicData>
+        </a:graphic>
+      </p:graphicFrame>
       <p:pic>
         <p:nvPicPr>
-          <p:cNvPr id="4" name="entries.png" descr="Expanded section with each entry read and its flag bits">    </p:cNvPr>
+          <p:cNvPr id="5" name="Hardware menu" descr="The Hardware menu with the switches">    </p:cNvPr>
+          <p:cNvPicPr>
+            <a:picLocks noChangeAspect="1"/>
+          </p:cNvPicPr>
+          <p:nvPr/>
+        </p:nvPicPr>
+        <p:blipFill>
+          <a:blip r:embed="rId2"/>
+          <a:stretch>
+            <a:fillRect/>
+          </a:stretch>
+        </p:blipFill>
+        <p:spPr>
+          <a:xfrm>
+            <a:off x="9052560" y="1737360"/>
+            <a:ext cx="1917303" cy="2423160"/>
+          </a:xfrm>
+          <a:prstGeom prst="rect">
+            <a:avLst/>
+          </a:prstGeom>
+          <a:effectLst>
+            <a:outerShdw sx="100000" sy="100000" kx="0" ky="0" algn="bl" rotWithShape="0" blurRad="76200" dist="25400" dir="5400000">
+              <a:srgbClr val="9AA3AE">
+                <a:alpha val="35000"/>
+              </a:srgbClr>
+            </a:outerShdw>
+          </a:effectLst>
+        </p:spPr>
+      </p:pic>
+      <p:sp>
+        <p:nvSpPr>
+          <p:cNvPr id="6" name="Chart note"/>
+          <p:cNvSpPr txBox="1"/>
+          <p:nvPr/>
+        </p:nvSpPr>
+        <p:spPr>
+          <a:xfrm>
+            <a:off x="8915400" y="4434840"/>
+            <a:ext cx="2697480" cy="1463040"/>
+          </a:xfrm>
+          <a:prstGeom prst="rect">
+            <a:avLst/>
+          </a:prstGeom>
+          <a:noFill/>
+          <a:ln/>
+        </p:spPr>
+        <p:txBody>
+          <a:bodyPr wrap="square" lIns="0" tIns="0" rIns="0" bIns="0" rtlCol="0" anchor="t"/>
+          <a:lstStyle/>
+          <a:p>
+            <a:pPr indent="0" marL="0">
+              <a:buNone/>
+            </a:pPr>
+            <a:r>
+              <a:rPr lang="en-US" sz="1300" dirty="0">
+                <a:solidFill>
+                  <a:schemeClr val="tx2"/>
+                </a:solidFill>
+              </a:rPr>
+              <a:t>192 accesses: 64 heap pages written twice, plus 64 touches of the 4 MB buffer. Model output, not a hardware measurement.</a:t>
+            </a:r>
+            <a:endParaRPr lang="en-US" sz="1300" dirty="0"/>
+          </a:p>
+        </p:txBody>
+      </p:sp>
+      <p:sp>
+        <p:nvSpPr>
+          <p:cNvPr id="25" name="Slide Number Placeholder 0"/>
+          <p:cNvSpPr>
+            <a:spLocks noGrp="1"/>
+          </p:cNvSpPr>
+          <p:nvPr>
+            <p:ph type="sldNum" sz="quarter" idx="4294967295"/>
+          </p:nvPr>
+        </p:nvSpPr>
+        <p:spPr>
+          <a:xfrm>
+            <a:off x="11247120" y="6400800"/>
+            <a:ext cx="457200" cy="274320"/>
+          </a:xfrm>
+          <a:prstGeom prst="rect">
+            <a:avLst/>
+          </a:prstGeom>
+          <a:extLst>
+            <a:ext uri="{C572A759-6A51-4108-AA02-DFA0A04FC94B}">
+              <ma14:wrappingTextBoxFlag xmlns:ma14="http://schemas.microsoft.com/office/mac/drawingml/2011/main" val="0"/>
+            </a:ext>
+          </a:extLst>
+        </p:spPr>
+        <p:txBody>
+          <a:bodyPr/>
+          <a:lstStyle>
+            <a:lvl1pPr>
+              <a:defRPr sz="1000">
+                <a:solidFill>
+                  <a:srgbClr val="8A93A0"/>
+                </a:solidFill>
+              </a:defRPr>
+            </a:lvl1pPr>
+          </a:lstStyle>
+          <a:p>
+            <a:pPr algn="r"/>
+            <a:fld id="{F7021451-1387-4CA6-816F-3879F97B5CBC}" type="slidenum">
+              <a:rPr b="0" lang="en-US"/>
+              <a:t>10</a:t>
+            </a:fld>
+            <a:endParaRPr lang="en-US"/>
+          </a:p>
+        </p:txBody>
+      </p:sp>
+    </p:spTree>
+  </p:cSld>
+  <p:clrMapOvr>
+    <a:masterClrMapping/>
+  </p:clrMapOvr>
+</p:sld>
+</file>
+
+<file path=ppt/slides/slide11.xml><?xml version="1.0" encoding="utf-8"?>
+<p:sld xmlns:a="http://schemas.openxmlformats.org/drawingml/2006/main" xmlns:r="http://schemas.openxmlformats.org/officeDocument/2006/relationships" xmlns:p="http://schemas.openxmlformats.org/presentationml/2006/main">
+  <p:cSld name="Slide 11">
+    <p:spTree>
+      <p:nvGrpSpPr>
+        <p:cNvPr id="1" name=""/>
+        <p:cNvGrpSpPr/>
+        <p:nvPr/>
+      </p:nvGrpSpPr>
+      <p:grpSpPr>
+        <a:xfrm>
+          <a:off x="0" y="0"/>
+          <a:ext cx="0" cy="0"/>
+          <a:chOff x="0" y="0"/>
+          <a:chExt cx="0" cy="0"/>
+        </a:xfrm>
+      </p:grpSpPr>
+      <p:sp>
+        <p:nvSpPr>
+          <p:cNvPr id="2" name="Text 1"/>
+          <p:cNvSpPr/>
+          <p:nvPr>
+            <p:ph idx="101" type="body" hasCustomPrompt="1"/>
+          </p:nvPr>
+        </p:nvSpPr>
+        <p:spPr>
+          <a:xfrm>
+            <a:off x="548640" y="365760"/>
+            <a:ext cx="10972800" cy="320040"/>
+          </a:xfrm>
+          <a:prstGeom prst="rect">
+            <a:avLst/>
+          </a:prstGeom>
+          <a:noFill/>
+          <a:ln/>
+        </p:spPr>
+        <p:txBody>
+          <a:bodyPr wrap="square" lIns="0" tIns="0" rIns="0" bIns="0" rtlCol="0"/>
+          <a:lstStyle/>
+          <a:p>
+            <a:pPr indent="0" marL="0">
+              <a:buNone/>
+            </a:pPr>
+            <a:r>
+              <a:rPr lang="en-US" sz="1300" b="1" spc="300" kern="0" dirty="0">
+                <a:solidFill>
+                  <a:schemeClr val="accent1"/>
+                </a:solidFill>
+              </a:rPr>
+              <a:t>REAL HARDWARE</a:t>
+            </a:r>
+            <a:endParaRPr lang="en-US" sz="1300" dirty="0"/>
+          </a:p>
+        </p:txBody>
+      </p:sp>
+      <p:sp>
+        <p:nvSpPr>
+          <p:cNvPr id="3" name="Text 1"/>
+          <p:cNvSpPr/>
+          <p:nvPr>
+            <p:ph idx="102" type="title" hasCustomPrompt="1"/>
+          </p:nvPr>
+        </p:nvSpPr>
+        <p:spPr>
+          <a:xfrm>
+            <a:off x="548640" y="685800"/>
+            <a:ext cx="11064240" cy="777240"/>
+          </a:xfrm>
+          <a:prstGeom prst="rect">
+            <a:avLst/>
+          </a:prstGeom>
+          <a:noFill/>
+          <a:ln/>
+        </p:spPr>
+        <p:txBody>
+          <a:bodyPr wrap="square" lIns="0" tIns="0" rIns="0" bIns="0" rtlCol="0" anchor="t"/>
+          <a:lstStyle/>
+          <a:p>
+            <a:pPr algn="l" indent="0" marL="0">
+              <a:buNone/>
+            </a:pPr>
+            <a:r>
+              <a:rPr lang="en-US" sz="3200" b="1" dirty="0">
+                <a:solidFill>
+                  <a:schemeClr val="tx1"/>
+                </a:solidFill>
+                <a:latin typeface="Cambria" pitchFamily="34" charset="0"/>
+                <a:ea typeface="Cambria" pitchFamily="34" charset="-122"/>
+                <a:cs typeface="Cambria" pitchFamily="34" charset="-120"/>
+              </a:rPr>
+              <a:t>Measured, not modelled: the page walk on a real CPU</a:t>
+            </a:r>
+            <a:endParaRPr lang="en-US" sz="3200" dirty="0"/>
+          </a:p>
+        </p:txBody>
+      </p:sp>
+      <p:pic>
+        <p:nvPicPr>
+          <p:cNvPr id="4" name="measure.png" descr="Browser measurement: time per read for spread and packed pages">    </p:cNvPr>
           <p:cNvPicPr>
             <a:picLocks noChangeAspect="1"/>
           </p:cNvPicPr>
@@ -2970,7 +3388,7 @@
         <p:spPr>
           <a:xfrm>
             <a:off x="548640" y="1645920"/>
-            <a:ext cx="7132320" cy="4184200"/>
+            <a:ext cx="7680960" cy="3924333"/>
           </a:xfrm>
           <a:prstGeom prst="rect">
             <a:avLst/>
@@ -2984,9 +3402,375 @@
           </a:effectLst>
         </p:spPr>
       </p:pic>
+      <p:sp>
+        <p:nvSpPr>
+          <p:cNvPr id="5" name="Gap value"/>
+          <p:cNvSpPr txBox="1"/>
+          <p:nvPr/>
+        </p:nvSpPr>
+        <p:spPr>
+          <a:xfrm>
+            <a:off x="8778240" y="1783080"/>
+            <a:ext cx="2834640" cy="685800"/>
+          </a:xfrm>
+          <a:prstGeom prst="rect">
+            <a:avLst/>
+          </a:prstGeom>
+          <a:noFill/>
+          <a:ln/>
+        </p:spPr>
+        <p:txBody>
+          <a:bodyPr wrap="square" lIns="0" tIns="0" rIns="0" bIns="0" rtlCol="0" anchor="ctr"/>
+          <a:lstStyle/>
+          <a:p>
+            <a:pPr indent="0" marL="0">
+              <a:buNone/>
+            </a:pPr>
+            <a:r>
+              <a:rPr lang="en-US" sz="4000" b="1" dirty="0">
+                <a:solidFill>
+                  <a:schemeClr val="accent1"/>
+                </a:solidFill>
+                <a:latin typeface="Cambria" pitchFamily="34" charset="0"/>
+                <a:ea typeface="Cambria" pitchFamily="34" charset="-122"/>
+                <a:cs typeface="Cambria" pitchFamily="34" charset="-120"/>
+              </a:rPr>
+              <a:t>3.3–3.6×</a:t>
+            </a:r>
+            <a:endParaRPr lang="en-US" sz="4000" dirty="0"/>
+          </a:p>
+        </p:txBody>
+      </p:sp>
+      <p:sp>
+        <p:nvSpPr>
+          <p:cNvPr id="6" name="Gap label"/>
+          <p:cNvSpPr txBox="1"/>
+          <p:nvPr/>
+        </p:nvSpPr>
+        <p:spPr>
+          <a:xfrm>
+            <a:off x="8778240" y="2496312"/>
+            <a:ext cx="2834640" cy="548640"/>
+          </a:xfrm>
+          <a:prstGeom prst="rect">
+            <a:avLst/>
+          </a:prstGeom>
+          <a:noFill/>
+          <a:ln/>
+        </p:spPr>
+        <p:txBody>
+          <a:bodyPr wrap="square" lIns="0" tIns="0" rIns="0" bIns="0" rtlCol="0" anchor="t"/>
+          <a:lstStyle/>
+          <a:p>
+            <a:pPr indent="0" marL="0">
+              <a:buNone/>
+            </a:pPr>
+            <a:r>
+              <a:rPr lang="en-US" sz="1400" dirty="0">
+                <a:solidFill>
+                  <a:schemeClr val="tx2"/>
+                </a:solidFill>
+              </a:rPr>
+              <a:t>slower per read at 16 MB when every read lands on a different page</a:t>
+            </a:r>
+            <a:endParaRPr lang="en-US" sz="1400" dirty="0"/>
+          </a:p>
+        </p:txBody>
+      </p:sp>
+      <p:sp>
+        <p:nvSpPr>
+          <p:cNvPr id="7" name="Knee value"/>
+          <p:cNvSpPr txBox="1"/>
+          <p:nvPr/>
+        </p:nvSpPr>
+        <p:spPr>
+          <a:xfrm>
+            <a:off x="8778240" y="3246120"/>
+            <a:ext cx="2834640" cy="685800"/>
+          </a:xfrm>
+          <a:prstGeom prst="rect">
+            <a:avLst/>
+          </a:prstGeom>
+          <a:noFill/>
+          <a:ln/>
+        </p:spPr>
+        <p:txBody>
+          <a:bodyPr wrap="square" lIns="0" tIns="0" rIns="0" bIns="0" rtlCol="0" anchor="ctr"/>
+          <a:lstStyle/>
+          <a:p>
+            <a:pPr indent="0" marL="0">
+              <a:buNone/>
+            </a:pPr>
+            <a:r>
+              <a:rPr lang="en-US" sz="4000" b="1" dirty="0">
+                <a:solidFill>
+                  <a:schemeClr val="accent2"/>
+                </a:solidFill>
+                <a:latin typeface="Cambria" pitchFamily="34" charset="0"/>
+                <a:ea typeface="Cambria" pitchFamily="34" charset="-122"/>
+                <a:cs typeface="Cambria" pitchFamily="34" charset="-120"/>
+              </a:rPr>
+              <a:t>≈ 64 pages</a:t>
+            </a:r>
+            <a:endParaRPr lang="en-US" sz="4000" dirty="0"/>
+          </a:p>
+        </p:txBody>
+      </p:sp>
+      <p:sp>
+        <p:nvSpPr>
+          <p:cNvPr id="8" name="Knee label"/>
+          <p:cNvSpPr txBox="1"/>
+          <p:nvPr/>
+        </p:nvSpPr>
+        <p:spPr>
+          <a:xfrm>
+            <a:off x="8778240" y="3959352"/>
+            <a:ext cx="2834640" cy="548640"/>
+          </a:xfrm>
+          <a:prstGeom prst="rect">
+            <a:avLst/>
+          </a:prstGeom>
+          <a:noFill/>
+          <a:ln/>
+        </p:spPr>
+        <p:txBody>
+          <a:bodyPr wrap="square" lIns="0" tIns="0" rIns="0" bIns="0" rtlCol="0" anchor="t"/>
+          <a:lstStyle/>
+          <a:p>
+            <a:pPr indent="0" marL="0">
+              <a:buNone/>
+            </a:pPr>
+            <a:r>
+              <a:rPr lang="en-US" sz="1400" dirty="0">
+                <a:solidFill>
+                  <a:schemeClr val="tx2"/>
+                </a:solidFill>
+              </a:rPr>
+              <a:t>where the gap starts: the size of a first-level TLB</a:t>
+            </a:r>
+            <a:endParaRPr lang="en-US" sz="1400" dirty="0"/>
+          </a:p>
+        </p:txBody>
+      </p:sp>
+      <p:sp>
+        <p:nvSpPr>
+          <p:cNvPr id="9" name="Method note"/>
+          <p:cNvSpPr txBox="1"/>
+          <p:nvPr/>
+        </p:nvSpPr>
+        <p:spPr>
+          <a:xfrm>
+            <a:off x="8778240" y="4663440"/>
+            <a:ext cx="2834640" cy="1463040"/>
+          </a:xfrm>
+          <a:prstGeom prst="rect">
+            <a:avLst/>
+          </a:prstGeom>
+          <a:noFill/>
+          <a:ln/>
+        </p:spPr>
+        <p:txBody>
+          <a:bodyPr wrap="square" lIns="0" tIns="0" rIns="0" bIns="0" rtlCol="0" anchor="t"/>
+          <a:lstStyle/>
+          <a:p>
+            <a:pPr indent="0" marL="0">
+              <a:buNone/>
+            </a:pPr>
+            <a:r>
+              <a:rPr lang="en-US" sz="1300" dirty="0">
+                <a:solidFill>
+                  <a:schemeClr val="tx2"/>
+                </a:solidFill>
+              </a:rPr>
+              <a:t>Same number of reads both ways; only the number of pages differs, so the gap is translation cost. Our laptop, Chromium, two runs. Each viewer measures their own machine.</a:t>
+            </a:r>
+            <a:endParaRPr lang="en-US" sz="1300" dirty="0"/>
+          </a:p>
+        </p:txBody>
+      </p:sp>
+      <p:sp>
+        <p:nvSpPr>
+          <p:cNvPr id="25" name="Slide Number Placeholder 0"/>
+          <p:cNvSpPr>
+            <a:spLocks noGrp="1"/>
+          </p:cNvSpPr>
+          <p:nvPr>
+            <p:ph type="sldNum" sz="quarter" idx="4294967295"/>
+          </p:nvPr>
+        </p:nvSpPr>
+        <p:spPr>
+          <a:xfrm>
+            <a:off x="11247120" y="6400800"/>
+            <a:ext cx="457200" cy="274320"/>
+          </a:xfrm>
+          <a:prstGeom prst="rect">
+            <a:avLst/>
+          </a:prstGeom>
+          <a:extLst>
+            <a:ext uri="{C572A759-6A51-4108-AA02-DFA0A04FC94B}">
+              <ma14:wrappingTextBoxFlag xmlns:ma14="http://schemas.microsoft.com/office/mac/drawingml/2011/main" val="0"/>
+            </a:ext>
+          </a:extLst>
+        </p:spPr>
+        <p:txBody>
+          <a:bodyPr/>
+          <a:lstStyle>
+            <a:lvl1pPr>
+              <a:defRPr sz="1000">
+                <a:solidFill>
+                  <a:srgbClr val="8A93A0"/>
+                </a:solidFill>
+              </a:defRPr>
+            </a:lvl1pPr>
+          </a:lstStyle>
+          <a:p>
+            <a:pPr algn="r"/>
+            <a:fld id="{F7021451-1387-4CA6-816F-3879F97B5CBC}" type="slidenum">
+              <a:rPr b="0" lang="en-US"/>
+              <a:t>11</a:t>
+            </a:fld>
+            <a:endParaRPr lang="en-US"/>
+          </a:p>
+        </p:txBody>
+      </p:sp>
+    </p:spTree>
+  </p:cSld>
+  <p:clrMapOvr>
+    <a:masterClrMapping/>
+  </p:clrMapOvr>
+</p:sld>
+</file>
+
+<file path=ppt/slides/slide12.xml><?xml version="1.0" encoding="utf-8"?>
+<p:sld xmlns:a="http://schemas.openxmlformats.org/drawingml/2006/main" xmlns:r="http://schemas.openxmlformats.org/officeDocument/2006/relationships" xmlns:p="http://schemas.openxmlformats.org/presentationml/2006/main">
+  <p:cSld name="Slide 12">
+    <p:spTree>
+      <p:nvGrpSpPr>
+        <p:cNvPr id="1" name=""/>
+        <p:cNvGrpSpPr/>
+        <p:nvPr/>
+      </p:nvGrpSpPr>
+      <p:grpSpPr>
+        <a:xfrm>
+          <a:off x="0" y="0"/>
+          <a:ext cx="0" cy="0"/>
+          <a:chOff x="0" y="0"/>
+          <a:chExt cx="0" cy="0"/>
+        </a:xfrm>
+      </p:grpSpPr>
+      <p:sp>
+        <p:nvSpPr>
+          <p:cNvPr id="2" name="Text 1"/>
+          <p:cNvSpPr/>
+          <p:nvPr>
+            <p:ph idx="101" type="body" hasCustomPrompt="1"/>
+          </p:nvPr>
+        </p:nvSpPr>
+        <p:spPr>
+          <a:xfrm>
+            <a:off x="548640" y="365760"/>
+            <a:ext cx="10972800" cy="320040"/>
+          </a:xfrm>
+          <a:prstGeom prst="rect">
+            <a:avLst/>
+          </a:prstGeom>
+          <a:noFill/>
+          <a:ln/>
+        </p:spPr>
+        <p:txBody>
+          <a:bodyPr wrap="square" lIns="0" tIns="0" rIns="0" bIns="0" rtlCol="0"/>
+          <a:lstStyle/>
+          <a:p>
+            <a:pPr indent="0" marL="0">
+              <a:buNone/>
+            </a:pPr>
+            <a:r>
+              <a:rPr lang="en-US" sz="1300" b="1" spc="300" kern="0" dirty="0">
+                <a:solidFill>
+                  <a:schemeClr val="accent1"/>
+                </a:solidFill>
+              </a:rPr>
+              <a:t>FOR QUESTIONS</a:t>
+            </a:r>
+            <a:endParaRPr lang="en-US" sz="1300" dirty="0"/>
+          </a:p>
+        </p:txBody>
+      </p:sp>
+      <p:sp>
+        <p:nvSpPr>
+          <p:cNvPr id="3" name="Text 1"/>
+          <p:cNvSpPr/>
+          <p:nvPr>
+            <p:ph idx="102" type="title" hasCustomPrompt="1"/>
+          </p:nvPr>
+        </p:nvSpPr>
+        <p:spPr>
+          <a:xfrm>
+            <a:off x="548640" y="685800"/>
+            <a:ext cx="11064240" cy="777240"/>
+          </a:xfrm>
+          <a:prstGeom prst="rect">
+            <a:avLst/>
+          </a:prstGeom>
+          <a:noFill/>
+          <a:ln/>
+        </p:spPr>
+        <p:txBody>
+          <a:bodyPr wrap="square" lIns="0" tIns="0" rIns="0" bIns="0" rtlCol="0" anchor="t"/>
+          <a:lstStyle/>
+          <a:p>
+            <a:pPr algn="l" indent="0" marL="0">
+              <a:buNone/>
+            </a:pPr>
+            <a:r>
+              <a:rPr lang="en-US" sz="3200" b="1" dirty="0">
+                <a:solidFill>
+                  <a:schemeClr val="tx1"/>
+                </a:solidFill>
+                <a:latin typeface="Cambria" pitchFamily="34" charset="0"/>
+                <a:ea typeface="Cambria" pitchFamily="34" charset="-122"/>
+                <a:cs typeface="Cambria" pitchFamily="34" charset="-120"/>
+              </a:rPr>
+              <a:t>The real entry bits are one click away</a:t>
+            </a:r>
+            <a:endParaRPr lang="en-US" sz="3200" dirty="0"/>
+          </a:p>
+        </p:txBody>
+      </p:sp>
+      <p:pic>
+        <p:nvPicPr>
+          <p:cNvPr id="4" name="entries.png" descr="Expanded section with each entry read and its flag bits">    </p:cNvPr>
+          <p:cNvPicPr>
+            <a:picLocks noChangeAspect="1"/>
+          </p:cNvPicPr>
+          <p:nvPr/>
+        </p:nvPicPr>
+        <p:blipFill>
+          <a:blip r:embed="rId1"/>
+          <a:stretch>
+            <a:fillRect/>
+          </a:stretch>
+        </p:blipFill>
+        <p:spPr>
+          <a:xfrm>
+            <a:off x="548640" y="1645920"/>
+            <a:ext cx="7132320" cy="4184200"/>
+          </a:xfrm>
+          <a:prstGeom prst="rect">
+            <a:avLst/>
+          </a:prstGeom>
+          <a:effectLst>
+            <a:outerShdw sx="100000" sy="100000" kx="0" ky="0" algn="bl" rotWithShape="0" blurRad="76200" dist="25400" dir="5400000">
+              <a:srgbClr val="9AA3AE">
+                <a:alpha val="35000"/>
+              </a:srgbClr>
+            </a:outerShdw>
+          </a:effectLst>
+        </p:spPr>
+      </p:pic>
       <p:graphicFrame>
         <p:nvGraphicFramePr>
-          <p:cNvPr id="11" name="Flag table"/>
+          <p:cNvPr id="13" name="Flag table"/>
           <p:cNvGraphicFramePr>
             <a:graphicFrameLocks noGrp="1"/>
           </p:cNvGraphicFramePr>
@@ -4081,7 +4865,7 @@
             <a:pPr algn="r"/>
             <a:fld id="{F7021451-1387-4CA6-816F-3879F97B5CBC}" type="slidenum">
               <a:rPr b="0" lang="en-US"/>
-              <a:t>10</a:t>
+              <a:t>12</a:t>
             </a:fld>
             <a:endParaRPr lang="en-US"/>
           </a:p>
@@ -4095,9 +4879,9 @@
 </p:sld>
 </file>
 
-<file path=ppt/slides/slide11.xml><?xml version="1.0" encoding="utf-8"?>
+<file path=ppt/slides/slide13.xml><?xml version="1.0" encoding="utf-8"?>
 <p:sld xmlns:a="http://schemas.openxmlformats.org/drawingml/2006/main" xmlns:r="http://schemas.openxmlformats.org/officeDocument/2006/relationships" xmlns:p="http://schemas.openxmlformats.org/presentationml/2006/main">
-  <p:cSld name="Slide 11">
+  <p:cSld name="Slide 13">
     <p:spTree>
       <p:nvGrpSpPr>
         <p:cNvPr id="1" name=""/>
@@ -4185,7 +4969,7 @@
                 <a:ea typeface="Cambria" pitchFamily="34" charset="-122"/>
                 <a:cs typeface="Cambria" pitchFamily="34" charset="-120"/>
               </a:rPr>
-              <a:t>Two new files, three updated, tests removed</a:t>
+              <a:t>Three new files, three updated</a:t>
             </a:r>
             <a:endParaRPr lang="en-US" sz="3200" dirty="0"/>
           </a:p>
@@ -4193,7 +4977,7 @@
       </p:sp>
       <p:graphicFrame>
         <p:nvGraphicFramePr>
-          <p:cNvPr id="12" name="Change table"/>
+          <p:cNvPr id="14" name="Change table"/>
           <p:cNvGraphicFramePr>
             <a:graphicFrameLocks noGrp="1"/>
           </p:cNvGraphicFramePr>
@@ -4214,11 +4998,11 @@
             <a:tbl>
               <a:tblPr/>
               <a:tblGrid>
-                <a:gridCol w="1920240"/>
-                <a:gridCol w="1097280"/>
+                <a:gridCol w="2011680"/>
+                <a:gridCol w="1005840"/>
                 <a:gridCol w="3931920"/>
               </a:tblGrid>
-              <a:tr h="566928">
+              <a:tr h="548640">
                 <a:tc>
                   <a:txBody>
                     <a:bodyPr/>
@@ -4403,7 +5187,7 @@
                   </a:tcPr>
                 </a:tc>
               </a:tr>
-              <a:tr h="566928">
+              <a:tr h="548640">
                 <a:tc>
                   <a:txBody>
                     <a:bodyPr/>
@@ -4540,7 +5324,7 @@
                             <a:srgbClr val="16202E"/>
                           </a:solidFill>
                         </a:rPr>
-                        <a:t>Model of the four-level walk: entry bits, faults, large pages, TLB, walk cache</a:t>
+                        <a:t>Model of the four-level walk: faults, large pages, TLB, walk cache, VM mode</a:t>
                       </a:r>
                       <a:endParaRPr lang="en-US" sz="1400" dirty="0"/>
                     </a:p>
@@ -4588,7 +5372,7 @@
                   </a:tcPr>
                 </a:tc>
               </a:tr>
-              <a:tr h="566928">
+              <a:tr h="548640">
                 <a:tc>
                   <a:txBody>
                     <a:bodyPr/>
@@ -4773,7 +5557,192 @@
                   </a:tcPr>
                 </a:tc>
               </a:tr>
-              <a:tr h="566928">
+              <a:tr h="548640">
+                <a:tc>
+                  <a:txBody>
+                    <a:bodyPr/>
+                    <a:lstStyle/>
+                    <a:p>
+                      <a:pPr indent="0" marL="0">
+                        <a:buNone/>
+                      </a:pPr>
+                      <a:r>
+                        <a:rPr lang="en-US" sz="1400" b="1" dirty="0">
+                          <a:solidFill>
+                            <a:srgbClr val="16202E"/>
+                          </a:solidFill>
+                        </a:rPr>
+                        <a:t>views/measure.html</a:t>
+                      </a:r>
+                      <a:endParaRPr lang="en-US" sz="1400" dirty="0"/>
+                    </a:p>
+                  </a:txBody>
+                  <a:tcPr marL="73152" marR="73152" marT="73152" marB="73152" anchor="ctr">
+                    <a:lnL w="6350" cap="flat" cmpd="sng" algn="ctr">
+                      <a:solidFill>
+                        <a:srgbClr val="D9DEE5"/>
+                      </a:solidFill>
+                      <a:prstDash val="solid"/>
+                      <a:round/>
+                      <a:headEnd type="none" w="med" len="med"/>
+                      <a:tailEnd type="none" w="med" len="med"/>
+                    </a:lnL>
+                    <a:lnR w="6350" cap="flat" cmpd="sng" algn="ctr">
+                      <a:solidFill>
+                        <a:srgbClr val="D9DEE5"/>
+                      </a:solidFill>
+                      <a:prstDash val="solid"/>
+                      <a:round/>
+                      <a:headEnd type="none" w="med" len="med"/>
+                      <a:tailEnd type="none" w="med" len="med"/>
+                    </a:lnR>
+                    <a:lnT w="6350" cap="flat" cmpd="sng" algn="ctr">
+                      <a:solidFill>
+                        <a:srgbClr val="D9DEE5"/>
+                      </a:solidFill>
+                      <a:prstDash val="solid"/>
+                      <a:round/>
+                      <a:headEnd type="none" w="med" len="med"/>
+                      <a:tailEnd type="none" w="med" len="med"/>
+                    </a:lnT>
+                    <a:lnB w="6350" cap="flat" cmpd="sng" algn="ctr">
+                      <a:solidFill>
+                        <a:srgbClr val="D9DEE5"/>
+                      </a:solidFill>
+                      <a:prstDash val="solid"/>
+                      <a:round/>
+                      <a:headEnd type="none" w="med" len="med"/>
+                      <a:tailEnd type="none" w="med" len="med"/>
+                    </a:lnB>
+                    <a:solidFill>
+                      <a:srgbClr val="F2F4F7"/>
+                    </a:solidFill>
+                  </a:tcPr>
+                </a:tc>
+                <a:tc>
+                  <a:txBody>
+                    <a:bodyPr/>
+                    <a:lstStyle/>
+                    <a:p>
+                      <a:pPr indent="0" marL="0">
+                        <a:buNone/>
+                      </a:pPr>
+                      <a:r>
+                        <a:rPr lang="en-US" sz="1400" b="1" dirty="0">
+                          <a:solidFill>
+                            <a:srgbClr val="1A7F5A"/>
+                          </a:solidFill>
+                        </a:rPr>
+                        <a:t>New</a:t>
+                      </a:r>
+                      <a:endParaRPr lang="en-US" sz="1400" dirty="0"/>
+                    </a:p>
+                  </a:txBody>
+                  <a:tcPr marL="73152" marR="73152" marT="73152" marB="73152" anchor="ctr">
+                    <a:lnL w="6350" cap="flat" cmpd="sng" algn="ctr">
+                      <a:solidFill>
+                        <a:srgbClr val="D9DEE5"/>
+                      </a:solidFill>
+                      <a:prstDash val="solid"/>
+                      <a:round/>
+                      <a:headEnd type="none" w="med" len="med"/>
+                      <a:tailEnd type="none" w="med" len="med"/>
+                    </a:lnL>
+                    <a:lnR w="6350" cap="flat" cmpd="sng" algn="ctr">
+                      <a:solidFill>
+                        <a:srgbClr val="D9DEE5"/>
+                      </a:solidFill>
+                      <a:prstDash val="solid"/>
+                      <a:round/>
+                      <a:headEnd type="none" w="med" len="med"/>
+                      <a:tailEnd type="none" w="med" len="med"/>
+                    </a:lnR>
+                    <a:lnT w="6350" cap="flat" cmpd="sng" algn="ctr">
+                      <a:solidFill>
+                        <a:srgbClr val="D9DEE5"/>
+                      </a:solidFill>
+                      <a:prstDash val="solid"/>
+                      <a:round/>
+                      <a:headEnd type="none" w="med" len="med"/>
+                      <a:tailEnd type="none" w="med" len="med"/>
+                    </a:lnT>
+                    <a:lnB w="6350" cap="flat" cmpd="sng" algn="ctr">
+                      <a:solidFill>
+                        <a:srgbClr val="D9DEE5"/>
+                      </a:solidFill>
+                      <a:prstDash val="solid"/>
+                      <a:round/>
+                      <a:headEnd type="none" w="med" len="med"/>
+                      <a:tailEnd type="none" w="med" len="med"/>
+                    </a:lnB>
+                    <a:solidFill>
+                      <a:srgbClr val="F2F4F7"/>
+                    </a:solidFill>
+                  </a:tcPr>
+                </a:tc>
+                <a:tc>
+                  <a:txBody>
+                    <a:bodyPr/>
+                    <a:lstStyle/>
+                    <a:p>
+                      <a:pPr indent="0" marL="0">
+                        <a:buNone/>
+                      </a:pPr>
+                      <a:r>
+                        <a:rPr lang="en-US" sz="1400" dirty="0">
+                          <a:solidFill>
+                            <a:srgbClr val="16202E"/>
+                          </a:solidFill>
+                        </a:rPr>
+                        <a:t>Real TLB test that runs in the viewer's browser</a:t>
+                      </a:r>
+                      <a:endParaRPr lang="en-US" sz="1400" dirty="0"/>
+                    </a:p>
+                  </a:txBody>
+                  <a:tcPr marL="73152" marR="73152" marT="73152" marB="73152" anchor="ctr">
+                    <a:lnL w="6350" cap="flat" cmpd="sng" algn="ctr">
+                      <a:solidFill>
+                        <a:srgbClr val="D9DEE5"/>
+                      </a:solidFill>
+                      <a:prstDash val="solid"/>
+                      <a:round/>
+                      <a:headEnd type="none" w="med" len="med"/>
+                      <a:tailEnd type="none" w="med" len="med"/>
+                    </a:lnL>
+                    <a:lnR w="6350" cap="flat" cmpd="sng" algn="ctr">
+                      <a:solidFill>
+                        <a:srgbClr val="D9DEE5"/>
+                      </a:solidFill>
+                      <a:prstDash val="solid"/>
+                      <a:round/>
+                      <a:headEnd type="none" w="med" len="med"/>
+                      <a:tailEnd type="none" w="med" len="med"/>
+                    </a:lnR>
+                    <a:lnT w="6350" cap="flat" cmpd="sng" algn="ctr">
+                      <a:solidFill>
+                        <a:srgbClr val="D9DEE5"/>
+                      </a:solidFill>
+                      <a:prstDash val="solid"/>
+                      <a:round/>
+                      <a:headEnd type="none" w="med" len="med"/>
+                      <a:tailEnd type="none" w="med" len="med"/>
+                    </a:lnT>
+                    <a:lnB w="6350" cap="flat" cmpd="sng" algn="ctr">
+                      <a:solidFill>
+                        <a:srgbClr val="D9DEE5"/>
+                      </a:solidFill>
+                      <a:prstDash val="solid"/>
+                      <a:round/>
+                      <a:headEnd type="none" w="med" len="med"/>
+                      <a:tailEnd type="none" w="med" len="med"/>
+                    </a:lnB>
+                    <a:solidFill>
+                      <a:srgbClr val="F2F4F7"/>
+                    </a:solidFill>
+                  </a:tcPr>
+                </a:tc>
+              </a:tr>
+              <a:tr h="548640">
                 <a:tc>
                   <a:txBody>
                     <a:bodyPr/>
@@ -4958,7 +5927,7 @@
                   </a:tcPr>
                 </a:tc>
               </a:tr>
-              <a:tr h="566928">
+              <a:tr h="548640">
                 <a:tc>
                   <a:txBody>
                     <a:bodyPr/>
@@ -5143,191 +6112,6 @@
                   </a:tcPr>
                 </a:tc>
               </a:tr>
-              <a:tr h="566928">
-                <a:tc>
-                  <a:txBody>
-                    <a:bodyPr/>
-                    <a:lstStyle/>
-                    <a:p>
-                      <a:pPr indent="0" marL="0">
-                        <a:buNone/>
-                      </a:pPr>
-                      <a:r>
-                        <a:rPr lang="en-US" sz="1400" b="1" dirty="0">
-                          <a:solidFill>
-                            <a:srgbClr val="16202E"/>
-                          </a:solidFill>
-                        </a:rPr>
-                        <a:t>tests/</a:t>
-                      </a:r>
-                      <a:endParaRPr lang="en-US" sz="1400" dirty="0"/>
-                    </a:p>
-                  </a:txBody>
-                  <a:tcPr marL="73152" marR="73152" marT="73152" marB="73152" anchor="ctr">
-                    <a:lnL w="6350" cap="flat" cmpd="sng" algn="ctr">
-                      <a:solidFill>
-                        <a:srgbClr val="D9DEE5"/>
-                      </a:solidFill>
-                      <a:prstDash val="solid"/>
-                      <a:round/>
-                      <a:headEnd type="none" w="med" len="med"/>
-                      <a:tailEnd type="none" w="med" len="med"/>
-                    </a:lnL>
-                    <a:lnR w="6350" cap="flat" cmpd="sng" algn="ctr">
-                      <a:solidFill>
-                        <a:srgbClr val="D9DEE5"/>
-                      </a:solidFill>
-                      <a:prstDash val="solid"/>
-                      <a:round/>
-                      <a:headEnd type="none" w="med" len="med"/>
-                      <a:tailEnd type="none" w="med" len="med"/>
-                    </a:lnR>
-                    <a:lnT w="6350" cap="flat" cmpd="sng" algn="ctr">
-                      <a:solidFill>
-                        <a:srgbClr val="D9DEE5"/>
-                      </a:solidFill>
-                      <a:prstDash val="solid"/>
-                      <a:round/>
-                      <a:headEnd type="none" w="med" len="med"/>
-                      <a:tailEnd type="none" w="med" len="med"/>
-                    </a:lnT>
-                    <a:lnB w="6350" cap="flat" cmpd="sng" algn="ctr">
-                      <a:solidFill>
-                        <a:srgbClr val="D9DEE5"/>
-                      </a:solidFill>
-                      <a:prstDash val="solid"/>
-                      <a:round/>
-                      <a:headEnd type="none" w="med" len="med"/>
-                      <a:tailEnd type="none" w="med" len="med"/>
-                    </a:lnB>
-                    <a:solidFill>
-                      <a:srgbClr val="F2F4F7"/>
-                    </a:solidFill>
-                  </a:tcPr>
-                </a:tc>
-                <a:tc>
-                  <a:txBody>
-                    <a:bodyPr/>
-                    <a:lstStyle/>
-                    <a:p>
-                      <a:pPr indent="0" marL="0">
-                        <a:buNone/>
-                      </a:pPr>
-                      <a:r>
-                        <a:rPr lang="en-US" sz="1400" b="1" dirty="0">
-                          <a:solidFill>
-                            <a:srgbClr val="B44D14"/>
-                          </a:solidFill>
-                        </a:rPr>
-                        <a:t>Removed</a:t>
-                      </a:r>
-                      <a:endParaRPr lang="en-US" sz="1400" dirty="0"/>
-                    </a:p>
-                  </a:txBody>
-                  <a:tcPr marL="73152" marR="73152" marT="73152" marB="73152" anchor="ctr">
-                    <a:lnL w="6350" cap="flat" cmpd="sng" algn="ctr">
-                      <a:solidFill>
-                        <a:srgbClr val="D9DEE5"/>
-                      </a:solidFill>
-                      <a:prstDash val="solid"/>
-                      <a:round/>
-                      <a:headEnd type="none" w="med" len="med"/>
-                      <a:tailEnd type="none" w="med" len="med"/>
-                    </a:lnL>
-                    <a:lnR w="6350" cap="flat" cmpd="sng" algn="ctr">
-                      <a:solidFill>
-                        <a:srgbClr val="D9DEE5"/>
-                      </a:solidFill>
-                      <a:prstDash val="solid"/>
-                      <a:round/>
-                      <a:headEnd type="none" w="med" len="med"/>
-                      <a:tailEnd type="none" w="med" len="med"/>
-                    </a:lnR>
-                    <a:lnT w="6350" cap="flat" cmpd="sng" algn="ctr">
-                      <a:solidFill>
-                        <a:srgbClr val="D9DEE5"/>
-                      </a:solidFill>
-                      <a:prstDash val="solid"/>
-                      <a:round/>
-                      <a:headEnd type="none" w="med" len="med"/>
-                      <a:tailEnd type="none" w="med" len="med"/>
-                    </a:lnT>
-                    <a:lnB w="6350" cap="flat" cmpd="sng" algn="ctr">
-                      <a:solidFill>
-                        <a:srgbClr val="D9DEE5"/>
-                      </a:solidFill>
-                      <a:prstDash val="solid"/>
-                      <a:round/>
-                      <a:headEnd type="none" w="med" len="med"/>
-                      <a:tailEnd type="none" w="med" len="med"/>
-                    </a:lnB>
-                    <a:solidFill>
-                      <a:srgbClr val="F2F4F7"/>
-                    </a:solidFill>
-                  </a:tcPr>
-                </a:tc>
-                <a:tc>
-                  <a:txBody>
-                    <a:bodyPr/>
-                    <a:lstStyle/>
-                    <a:p>
-                      <a:pPr indent="0" marL="0">
-                        <a:buNone/>
-                      </a:pPr>
-                      <a:r>
-                        <a:rPr lang="en-US" sz="1400" dirty="0">
-                          <a:solidFill>
-                            <a:srgbClr val="16202E"/>
-                          </a:solidFill>
-                        </a:rPr>
-                        <a:t>Not needed for the hosted app</a:t>
-                      </a:r>
-                      <a:endParaRPr lang="en-US" sz="1400" dirty="0"/>
-                    </a:p>
-                  </a:txBody>
-                  <a:tcPr marL="73152" marR="73152" marT="73152" marB="73152" anchor="ctr">
-                    <a:lnL w="6350" cap="flat" cmpd="sng" algn="ctr">
-                      <a:solidFill>
-                        <a:srgbClr val="D9DEE5"/>
-                      </a:solidFill>
-                      <a:prstDash val="solid"/>
-                      <a:round/>
-                      <a:headEnd type="none" w="med" len="med"/>
-                      <a:tailEnd type="none" w="med" len="med"/>
-                    </a:lnL>
-                    <a:lnR w="6350" cap="flat" cmpd="sng" algn="ctr">
-                      <a:solidFill>
-                        <a:srgbClr val="D9DEE5"/>
-                      </a:solidFill>
-                      <a:prstDash val="solid"/>
-                      <a:round/>
-                      <a:headEnd type="none" w="med" len="med"/>
-                      <a:tailEnd type="none" w="med" len="med"/>
-                    </a:lnR>
-                    <a:lnT w="6350" cap="flat" cmpd="sng" algn="ctr">
-                      <a:solidFill>
-                        <a:srgbClr val="D9DEE5"/>
-                      </a:solidFill>
-                      <a:prstDash val="solid"/>
-                      <a:round/>
-                      <a:headEnd type="none" w="med" len="med"/>
-                      <a:tailEnd type="none" w="med" len="med"/>
-                    </a:lnT>
-                    <a:lnB w="6350" cap="flat" cmpd="sng" algn="ctr">
-                      <a:solidFill>
-                        <a:srgbClr val="D9DEE5"/>
-                      </a:solidFill>
-                      <a:prstDash val="solid"/>
-                      <a:round/>
-                      <a:headEnd type="none" w="med" len="med"/>
-                      <a:tailEnd type="none" w="med" len="med"/>
-                    </a:lnB>
-                    <a:solidFill>
-                      <a:srgbClr val="F2F4F7"/>
-                    </a:solidFill>
-                  </a:tcPr>
-                </a:tc>
-              </a:tr>
             </a:tbl>
           </a:graphicData>
         </a:graphic>
@@ -5483,7 +6267,7 @@
                   <a:schemeClr val="tx1"/>
                 </a:solidFill>
               </a:rPr>
-              <a:t>Each click is a few microseconds of Python</a:t>
+              <a:t>The hardware test runs in the viewer's browser, not on the server</a:t>
             </a:r>
             <a:endParaRPr lang="en-US" sz="1500" dirty="0"/>
           </a:p>
@@ -5528,7 +6312,7 @@
             <a:pPr algn="r"/>
             <a:fld id="{F7021451-1387-4CA6-816F-3879F97B5CBC}" type="slidenum">
               <a:rPr b="0" lang="en-US"/>
-              <a:t>11</a:t>
+              <a:t>13</a:t>
             </a:fld>
             <a:endParaRPr lang="en-US"/>
           </a:p>
@@ -5542,9 +6326,9 @@
 </p:sld>
 </file>
 
-<file path=ppt/slides/slide12.xml><?xml version="1.0" encoding="utf-8"?>
+<file path=ppt/slides/slide14.xml><?xml version="1.0" encoding="utf-8"?>
 <p:sld xmlns:a="http://schemas.openxmlformats.org/drawingml/2006/main" xmlns:r="http://schemas.openxmlformats.org/officeDocument/2006/relationships" xmlns:p="http://schemas.openxmlformats.org/presentationml/2006/main">
-  <p:cSld name="Slide 12">
+  <p:cSld name="Slide 14">
     <p:spTree>
       <p:nvGrpSpPr>
         <p:cNvPr id="1" name=""/>
@@ -5591,7 +6375,7 @@
                   <a:srgbClr val="F2A65A"/>
                 </a:solidFill>
               </a:rPr>
-              <a:t>LIVE DEMO · ABOUT ONE MINUTE</a:t>
+              <a:t>LIVE DEMO · ABOUT TWO MINUTES</a:t>
             </a:r>
             <a:endParaRPr lang="en-US" sz="1400" dirty="0"/>
           </a:p>
@@ -5646,7 +6430,7 @@
         </p:nvSpPr>
         <p:spPr>
           <a:xfrm>
-            <a:off x="685800" y="2331720"/>
+            <a:off x="685800" y="2514600"/>
             <a:ext cx="502920" cy="502920"/>
           </a:xfrm>
           <a:prstGeom prst="ellipse">
@@ -5671,7 +6455,7 @@
         </p:nvSpPr>
         <p:spPr>
           <a:xfrm>
-            <a:off x="685800" y="2331720"/>
+            <a:off x="685800" y="2514600"/>
             <a:ext cx="502920" cy="502920"/>
           </a:xfrm>
           <a:prstGeom prst="rect">
@@ -5707,8 +6491,8 @@
         </p:nvSpPr>
         <p:spPr>
           <a:xfrm>
-            <a:off x="1371600" y="2331720"/>
-            <a:ext cx="9601200" cy="502920"/>
+            <a:off x="1371600" y="2514600"/>
+            <a:ext cx="4754880" cy="502920"/>
           </a:xfrm>
           <a:prstGeom prst="rect">
             <a:avLst/>
@@ -5729,7 +6513,7 @@
                   <a:srgbClr val="FFFFFF"/>
                 </a:solidFill>
               </a:rPr>
-              <a:t>New heap page: page fault, Windows builds the tables</a:t>
+              <a:t>New heap page: page fault, tables built</a:t>
             </a:r>
             <a:endParaRPr lang="en-US" sz="1800" dirty="0"/>
           </a:p>
@@ -5743,7 +6527,7 @@
         </p:nvSpPr>
         <p:spPr>
           <a:xfrm>
-            <a:off x="685800" y="3108960"/>
+            <a:off x="685800" y="3383280"/>
             <a:ext cx="502920" cy="502920"/>
           </a:xfrm>
           <a:prstGeom prst="ellipse">
@@ -5768,7 +6552,7 @@
         </p:nvSpPr>
         <p:spPr>
           <a:xfrm>
-            <a:off x="685800" y="3108960"/>
+            <a:off x="685800" y="3383280"/>
             <a:ext cx="502920" cy="502920"/>
           </a:xfrm>
           <a:prstGeom prst="rect">
@@ -5804,8 +6588,8 @@
         </p:nvSpPr>
         <p:spPr>
           <a:xfrm>
-            <a:off x="1371600" y="3108960"/>
-            <a:ext cx="9601200" cy="502920"/>
+            <a:off x="1371600" y="3383280"/>
+            <a:ext cx="4754880" cy="502920"/>
           </a:xfrm>
           <a:prstGeom prst="rect">
             <a:avLst/>
@@ -5826,7 +6610,7 @@
                   <a:srgbClr val="FFFFFF"/>
                 </a:solidFill>
               </a:rPr>
-              <a:t>New heap page again: the walk cache skips three levels</a:t>
+              <a:t>New heap page again: walk cache skips 3 levels</a:t>
             </a:r>
             <a:endParaRPr lang="en-US" sz="1800" dirty="0"/>
           </a:p>
@@ -5840,7 +6624,7 @@
         </p:nvSpPr>
         <p:spPr>
           <a:xfrm>
-            <a:off x="685800" y="3886200"/>
+            <a:off x="685800" y="4251960"/>
             <a:ext cx="502920" cy="502920"/>
           </a:xfrm>
           <a:prstGeom prst="ellipse">
@@ -5865,7 +6649,7 @@
         </p:nvSpPr>
         <p:spPr>
           <a:xfrm>
-            <a:off x="685800" y="3886200"/>
+            <a:off x="685800" y="4251960"/>
             <a:ext cx="502920" cy="502920"/>
           </a:xfrm>
           <a:prstGeom prst="rect">
@@ -5901,8 +6685,8 @@
         </p:nvSpPr>
         <p:spPr>
           <a:xfrm>
-            <a:off x="1371600" y="3886200"/>
-            <a:ext cx="9601200" cy="502920"/>
+            <a:off x="1371600" y="4251960"/>
+            <a:ext cx="4754880" cy="502920"/>
           </a:xfrm>
           <a:prstGeom prst="rect">
             <a:avLst/>
@@ -5937,7 +6721,7 @@
         </p:nvSpPr>
         <p:spPr>
           <a:xfrm>
-            <a:off x="685800" y="4663440"/>
+            <a:off x="685800" y="5120640"/>
             <a:ext cx="502920" cy="502920"/>
           </a:xfrm>
           <a:prstGeom prst="ellipse">
@@ -5962,7 +6746,7 @@
         </p:nvSpPr>
         <p:spPr>
           <a:xfrm>
-            <a:off x="685800" y="4663440"/>
+            <a:off x="685800" y="5120640"/>
             <a:ext cx="502920" cy="502920"/>
           </a:xfrm>
           <a:prstGeom prst="rect">
@@ -5998,8 +6782,8 @@
         </p:nvSpPr>
         <p:spPr>
           <a:xfrm>
-            <a:off x="1371600" y="4663440"/>
-            <a:ext cx="9601200" cy="502920"/>
+            <a:off x="1371600" y="5120640"/>
+            <a:ext cx="4754880" cy="502920"/>
           </a:xfrm>
           <a:prstGeom prst="rect">
             <a:avLst/>
@@ -6034,7 +6818,7 @@
         </p:nvSpPr>
         <p:spPr>
           <a:xfrm>
-            <a:off x="685800" y="5440680"/>
+            <a:off x="6263640" y="2514600"/>
             <a:ext cx="502920" cy="502920"/>
           </a:xfrm>
           <a:prstGeom prst="ellipse">
@@ -6059,7 +6843,7 @@
         </p:nvSpPr>
         <p:spPr>
           <a:xfrm>
-            <a:off x="685800" y="5440680"/>
+            <a:off x="6263640" y="2514600"/>
             <a:ext cx="502920" cy="502920"/>
           </a:xfrm>
           <a:prstGeom prst="rect">
@@ -6095,8 +6879,8 @@
         </p:nvSpPr>
         <p:spPr>
           <a:xfrm>
-            <a:off x="1371600" y="5440680"/>
-            <a:ext cx="9601200" cy="502920"/>
+            <a:off x="6949440" y="2514600"/>
+            <a:ext cx="4754880" cy="502920"/>
           </a:xfrm>
           <a:prstGeom prst="rect">
             <a:avLst/>
@@ -6117,7 +6901,201 @@
                   <a:srgbClr val="FFFFFF"/>
                 </a:solidFill>
               </a:rPr>
-              <a:t>Hardware: walk cache off, New heap page: all four levels read</a:t>
+              <a:t>Hardware → Inside a VM: 24 reads</a:t>
+            </a:r>
+            <a:endParaRPr lang="en-US" sz="1800" dirty="0"/>
+          </a:p>
+        </p:txBody>
+      </p:sp>
+      <p:sp>
+        <p:nvSpPr>
+          <p:cNvPr id="19" name="Step dot 6"/>
+          <p:cNvSpPr/>
+          <p:nvPr/>
+        </p:nvSpPr>
+        <p:spPr>
+          <a:xfrm>
+            <a:off x="6263640" y="3383280"/>
+            <a:ext cx="502920" cy="502920"/>
+          </a:xfrm>
+          <a:prstGeom prst="ellipse">
+            <a:avLst/>
+          </a:prstGeom>
+          <a:solidFill>
+            <a:srgbClr val="F2A65A"/>
+          </a:solidFill>
+          <a:ln w="12700">
+            <a:solidFill>
+              <a:srgbClr val="F2A65A"/>
+            </a:solidFill>
+            <a:prstDash val="solid"/>
+          </a:ln>
+        </p:spPr>
+      </p:sp>
+      <p:sp>
+        <p:nvSpPr>
+          <p:cNvPr id="20" name="Step number 6"/>
+          <p:cNvSpPr txBox="1"/>
+          <p:nvPr/>
+        </p:nvSpPr>
+        <p:spPr>
+          <a:xfrm>
+            <a:off x="6263640" y="3383280"/>
+            <a:ext cx="502920" cy="502920"/>
+          </a:xfrm>
+          <a:prstGeom prst="rect">
+            <a:avLst/>
+          </a:prstGeom>
+          <a:noFill/>
+          <a:ln/>
+        </p:spPr>
+        <p:txBody>
+          <a:bodyPr wrap="square" lIns="0" tIns="0" rIns="0" bIns="0" rtlCol="0" anchor="ctr"/>
+          <a:lstStyle/>
+          <a:p>
+            <a:pPr algn="ctr" indent="0" marL="0">
+              <a:buNone/>
+            </a:pPr>
+            <a:r>
+              <a:rPr lang="en-US" sz="1800" b="1" dirty="0">
+                <a:solidFill>
+                  <a:srgbClr val="16202E"/>
+                </a:solidFill>
+              </a:rPr>
+              <a:t>6</a:t>
+            </a:r>
+            <a:endParaRPr lang="en-US" sz="1800" dirty="0"/>
+          </a:p>
+        </p:txBody>
+      </p:sp>
+      <p:sp>
+        <p:nvSpPr>
+          <p:cNvPr id="21" name="Step 6"/>
+          <p:cNvSpPr txBox="1"/>
+          <p:nvPr/>
+        </p:nvSpPr>
+        <p:spPr>
+          <a:xfrm>
+            <a:off x="6949440" y="3383280"/>
+            <a:ext cx="4754880" cy="502920"/>
+          </a:xfrm>
+          <a:prstGeom prst="rect">
+            <a:avLst/>
+          </a:prstGeom>
+          <a:noFill/>
+          <a:ln/>
+        </p:spPr>
+        <p:txBody>
+          <a:bodyPr wrap="square" lIns="0" tIns="0" rIns="0" bIns="0" rtlCol="0" anchor="ctr"/>
+          <a:lstStyle/>
+          <a:p>
+            <a:pPr indent="0" marL="0">
+              <a:buNone/>
+            </a:pPr>
+            <a:r>
+              <a:rPr lang="en-US" sz="1800" dirty="0">
+                <a:solidFill>
+                  <a:srgbClr val="FFFFFF"/>
+                </a:solidFill>
+              </a:rPr>
+              <a:t>Hardware → walk cache off: compare the reads</a:t>
+            </a:r>
+            <a:endParaRPr lang="en-US" sz="1800" dirty="0"/>
+          </a:p>
+        </p:txBody>
+      </p:sp>
+      <p:sp>
+        <p:nvSpPr>
+          <p:cNvPr id="22" name="Step dot 7"/>
+          <p:cNvSpPr/>
+          <p:nvPr/>
+        </p:nvSpPr>
+        <p:spPr>
+          <a:xfrm>
+            <a:off x="6263640" y="4251960"/>
+            <a:ext cx="502920" cy="502920"/>
+          </a:xfrm>
+          <a:prstGeom prst="ellipse">
+            <a:avLst/>
+          </a:prstGeom>
+          <a:solidFill>
+            <a:srgbClr val="F2A65A"/>
+          </a:solidFill>
+          <a:ln w="12700">
+            <a:solidFill>
+              <a:srgbClr val="F2A65A"/>
+            </a:solidFill>
+            <a:prstDash val="solid"/>
+          </a:ln>
+        </p:spPr>
+      </p:sp>
+      <p:sp>
+        <p:nvSpPr>
+          <p:cNvPr id="23" name="Step number 7"/>
+          <p:cNvSpPr txBox="1"/>
+          <p:nvPr/>
+        </p:nvSpPr>
+        <p:spPr>
+          <a:xfrm>
+            <a:off x="6263640" y="4251960"/>
+            <a:ext cx="502920" cy="502920"/>
+          </a:xfrm>
+          <a:prstGeom prst="rect">
+            <a:avLst/>
+          </a:prstGeom>
+          <a:noFill/>
+          <a:ln/>
+        </p:spPr>
+        <p:txBody>
+          <a:bodyPr wrap="square" lIns="0" tIns="0" rIns="0" bIns="0" rtlCol="0" anchor="ctr"/>
+          <a:lstStyle/>
+          <a:p>
+            <a:pPr algn="ctr" indent="0" marL="0">
+              <a:buNone/>
+            </a:pPr>
+            <a:r>
+              <a:rPr lang="en-US" sz="1800" b="1" dirty="0">
+                <a:solidFill>
+                  <a:srgbClr val="16202E"/>
+                </a:solidFill>
+              </a:rPr>
+              <a:t>7</a:t>
+            </a:r>
+            <a:endParaRPr lang="en-US" sz="1800" dirty="0"/>
+          </a:p>
+        </p:txBody>
+      </p:sp>
+      <p:sp>
+        <p:nvSpPr>
+          <p:cNvPr id="24" name="Step 7"/>
+          <p:cNvSpPr txBox="1"/>
+          <p:nvPr/>
+        </p:nvSpPr>
+        <p:spPr>
+          <a:xfrm>
+            <a:off x="6949440" y="4251960"/>
+            <a:ext cx="4754880" cy="502920"/>
+          </a:xfrm>
+          <a:prstGeom prst="rect">
+            <a:avLst/>
+          </a:prstGeom>
+          <a:noFill/>
+          <a:ln/>
+        </p:spPr>
+        <p:txBody>
+          <a:bodyPr wrap="square" lIns="0" tIns="0" rIns="0" bIns="0" rtlCol="0" anchor="ctr"/>
+          <a:lstStyle/>
+          <a:p>
+            <a:pPr indent="0" marL="0">
+              <a:buNone/>
+            </a:pPr>
+            <a:r>
+              <a:rPr lang="en-US" sz="1800" dirty="0">
+                <a:solidFill>
+                  <a:srgbClr val="FFFFFF"/>
+                </a:solidFill>
+              </a:rPr>
+              <a:t>Measure this computer: real hardware, live</a:t>
             </a:r>
             <a:endParaRPr lang="en-US" sz="1800" dirty="0"/>
           </a:p>
@@ -6469,7 +7447,7 @@
                   <a:schemeClr val="tx1"/>
                 </a:solidFill>
               </a:rPr>
-              <a:t>A working model of the real four-level walk, its entry bits and its faults</a:t>
+              <a:t>A working model of the four-level walk, and of the 24-read walk inside a virtual machine</a:t>
             </a:r>
             <a:endParaRPr lang="en-US" sz="1700" dirty="0"/>
           </a:p>
@@ -6487,7 +7465,7 @@
                   <a:schemeClr val="tx1"/>
                 </a:solidFill>
               </a:rPr>
-              <a:t>One click per scenario; the walk animates level by level</a:t>
+              <a:t>A real hardware test that runs on the viewer's own computer</a:t>
             </a:r>
             <a:endParaRPr lang="en-US" sz="1700" dirty="0"/>
           </a:p>
@@ -6495,7 +7473,7 @@
       </p:sp>
       <p:sp>
         <p:nvSpPr>
-          <p:cNvPr id="11" name="Levels value"/>
+          <p:cNvPr id="11" name="VM value"/>
           <p:cNvSpPr txBox="1"/>
           <p:nvPr/>
         </p:nvSpPr>
@@ -6520,13 +7498,13 @@
             <a:r>
               <a:rPr lang="en-US" sz="4000" b="1" dirty="0">
                 <a:solidFill>
-                  <a:schemeClr val="accent1"/>
+                  <a:schemeClr val="accent6"/>
                 </a:solidFill>
                 <a:latin typeface="Cambria" pitchFamily="34" charset="0"/>
                 <a:ea typeface="Cambria" pitchFamily="34" charset="-122"/>
                 <a:cs typeface="Cambria" pitchFamily="34" charset="-120"/>
               </a:rPr>
-              <a:t>4 levels</a:t>
+              <a:t>4 → 24</a:t>
             </a:r>
             <a:endParaRPr lang="en-US" sz="4000" dirty="0"/>
           </a:p>
@@ -6534,7 +7512,7 @@
       </p:sp>
       <p:sp>
         <p:nvSpPr>
-          <p:cNvPr id="12" name="Levels label"/>
+          <p:cNvPr id="12" name="VM label"/>
           <p:cNvSpPr txBox="1"/>
           <p:nvPr/>
         </p:nvSpPr>
@@ -6562,7 +7540,7 @@
                   <a:schemeClr val="tx2"/>
                 </a:solidFill>
               </a:rPr>
-              <a:t>walked on every TLB miss, as on any 64-bit PC</a:t>
+              <a:t>reads per address walk, once Windows runs inside a virtual machine</a:t>
             </a:r>
             <a:endParaRPr lang="en-US" sz="1400" dirty="0"/>
           </a:p>
@@ -6570,7 +7548,7 @@
       </p:sp>
       <p:sp>
         <p:nvSpPr>
-          <p:cNvPr id="13" name="Scenarios value"/>
+          <p:cNvPr id="13" name="Measured value"/>
           <p:cNvSpPr txBox="1"/>
           <p:nvPr/>
         </p:nvSpPr>
@@ -6595,13 +7573,13 @@
             <a:r>
               <a:rPr lang="en-US" sz="4000" b="1" dirty="0">
                 <a:solidFill>
-                  <a:schemeClr val="accent2"/>
+                  <a:schemeClr val="accent1"/>
                 </a:solidFill>
                 <a:latin typeface="Cambria" pitchFamily="34" charset="0"/>
                 <a:ea typeface="Cambria" pitchFamily="34" charset="-122"/>
                 <a:cs typeface="Cambria" pitchFamily="34" charset="-120"/>
               </a:rPr>
-              <a:t>3</a:t>
+              <a:t>3.3–3.6×</a:t>
             </a:r>
             <a:endParaRPr lang="en-US" sz="4000" dirty="0"/>
           </a:p>
@@ -6609,7 +7587,7 @@
       </p:sp>
       <p:sp>
         <p:nvSpPr>
-          <p:cNvPr id="14" name="Scenarios label"/>
+          <p:cNvPr id="14" name="Measured label"/>
           <p:cNvSpPr txBox="1"/>
           <p:nvPr/>
         </p:nvSpPr>
@@ -6637,7 +7615,7 @@
                   <a:schemeClr val="tx2"/>
                 </a:solidFill>
               </a:rPr>
-              <a:t>one-click scenarios: page fault, TLB hit, large page</a:t>
+              <a:t>slower per read when every read needs a page walk, measured on our laptop</a:t>
             </a:r>
             <a:endParaRPr lang="en-US" sz="1400" dirty="0"/>
           </a:p>
@@ -9353,7 +10331,7 @@
                   <a:schemeClr val="accent1"/>
                 </a:solidFill>
               </a:rPr>
-              <a:t>THE LIVE TREE</a:t>
+              <a:t>HARDWARE · INSIDE A VIRTUAL MACHINE</a:t>
             </a:r>
             <a:endParaRPr lang="en-US" sz="1300" dirty="0"/>
           </a:p>
@@ -9394,7 +10372,7 @@
                 <a:ea typeface="Cambria" pitchFamily="34" charset="-122"/>
                 <a:cs typeface="Cambria" pitchFamily="34" charset="-120"/>
               </a:rPr>
-              <a:t>Page tables exist only where memory is used</a:t>
+              <a:t>Inside a virtual machine, 4 reads become 24</a:t>
             </a:r>
             <a:endParaRPr lang="en-US" sz="3200" dirty="0"/>
           </a:p>
@@ -9402,7 +10380,7 @@
       </p:sp>
       <p:pic>
         <p:nvPicPr>
-          <p:cNvPr id="4" name="tree.png" descr="The process's page-table tree after a few scenarios">    </p:cNvPr>
+          <p:cNvPr id="4" name="vm_first.png" descr="Walk inside a virtual machine: a 5 by 5 grid of 24 numbered reads">    </p:cNvPr>
           <p:cNvPicPr>
             <a:picLocks noChangeAspect="1"/>
           </p:cNvPicPr>
@@ -9417,7 +10395,7 @@
         <p:spPr>
           <a:xfrm>
             <a:off x="548640" y="1645920"/>
-            <a:ext cx="7863840" cy="4262148"/>
+            <a:ext cx="7589520" cy="4259341"/>
           </a:xfrm>
           <a:prstGeom prst="rect">
             <a:avLst/>
@@ -9433,14 +10411,14 @@
       </p:pic>
       <p:sp>
         <p:nvSpPr>
-          <p:cNvPr id="5" name="Tables value"/>
+          <p:cNvPr id="5" name="Per level value"/>
           <p:cNvSpPr txBox="1"/>
           <p:nvPr/>
         </p:nvSpPr>
         <p:spPr>
           <a:xfrm>
-            <a:off x="8915400" y="1828800"/>
-            <a:ext cx="2743200" cy="685800"/>
+            <a:off x="8686800" y="1783080"/>
+            <a:ext cx="2926080" cy="685800"/>
           </a:xfrm>
           <a:prstGeom prst="rect">
             <a:avLst/>
@@ -9458,13 +10436,13 @@
             <a:r>
               <a:rPr lang="en-US" sz="4000" b="1" dirty="0">
                 <a:solidFill>
-                  <a:schemeClr val="accent2"/>
+                  <a:schemeClr val="accent6"/>
                 </a:solidFill>
                 <a:latin typeface="Cambria" pitchFamily="34" charset="0"/>
                 <a:ea typeface="Cambria" pitchFamily="34" charset="-122"/>
                 <a:cs typeface="Cambria" pitchFamily="34" charset="-120"/>
               </a:rPr>
-              <a:t>8 tables</a:t>
+              <a:t>4 + 1</a:t>
             </a:r>
             <a:endParaRPr lang="en-US" sz="4000" dirty="0"/>
           </a:p>
@@ -9472,14 +10450,14 @@
       </p:sp>
       <p:sp>
         <p:nvSpPr>
-          <p:cNvPr id="6" name="Tables label"/>
+          <p:cNvPr id="6" name="Per level label"/>
           <p:cNvSpPr txBox="1"/>
           <p:nvPr/>
         </p:nvSpPr>
         <p:spPr>
           <a:xfrm>
-            <a:off x="8915400" y="2542032"/>
-            <a:ext cx="2743200" cy="548640"/>
+            <a:off x="8686800" y="2496312"/>
+            <a:ext cx="2926080" cy="548640"/>
           </a:xfrm>
           <a:prstGeom prst="rect">
             <a:avLst/>
@@ -9500,7 +10478,7 @@
                   <a:schemeClr val="tx2"/>
                 </a:solidFill>
               </a:rPr>
-              <a:t>Level 4 to Level 1, built on demand</a:t>
+              <a:t>per guest table: the host walks its 4 levels, then the entry is read</a:t>
             </a:r>
             <a:endParaRPr lang="en-US" sz="1400" dirty="0"/>
           </a:p>
@@ -9508,14 +10486,14 @@
       </p:sp>
       <p:sp>
         <p:nvSpPr>
-          <p:cNvPr id="7" name="Used value"/>
+          <p:cNvPr id="7" name="Total value"/>
           <p:cNvSpPr txBox="1"/>
           <p:nvPr/>
         </p:nvSpPr>
         <p:spPr>
           <a:xfrm>
-            <a:off x="8915400" y="3291840"/>
-            <a:ext cx="2743200" cy="685800"/>
+            <a:off x="8686800" y="3246120"/>
+            <a:ext cx="2926080" cy="685800"/>
           </a:xfrm>
           <a:prstGeom prst="rect">
             <a:avLst/>
@@ -9533,13 +10511,13 @@
             <a:r>
               <a:rPr lang="en-US" sz="4000" b="1" dirty="0">
                 <a:solidFill>
-                  <a:schemeClr val="accent3"/>
+                  <a:schemeClr val="accent1"/>
                 </a:solidFill>
                 <a:latin typeface="Cambria" pitchFamily="34" charset="0"/>
                 <a:ea typeface="Cambria" pitchFamily="34" charset="-122"/>
                 <a:cs typeface="Cambria" pitchFamily="34" charset="-120"/>
               </a:rPr>
-              <a:t>32 KB</a:t>
+              <a:t>24 reads</a:t>
             </a:r>
             <a:endParaRPr lang="en-US" sz="4000" dirty="0"/>
           </a:p>
@@ -9547,14 +10525,14 @@
       </p:sp>
       <p:sp>
         <p:nvSpPr>
-          <p:cNvPr id="8" name="Used label"/>
+          <p:cNvPr id="8" name="Total label"/>
           <p:cNvSpPr txBox="1"/>
           <p:nvPr/>
         </p:nvSpPr>
         <p:spPr>
           <a:xfrm>
-            <a:off x="8915400" y="4005072"/>
-            <a:ext cx="2743200" cy="548640"/>
+            <a:off x="8686800" y="3959352"/>
+            <a:ext cx="2926080" cy="548640"/>
           </a:xfrm>
           <a:prstGeom prst="rect">
             <a:avLst/>
@@ -9575,7 +10553,7 @@
                   <a:schemeClr val="tx2"/>
                 </a:solidFill>
               </a:rPr>
-              <a:t>of page-table memory for this process</a:t>
+              <a:t>for one address with nothing cached, against 4 on bare hardware</a:t>
             </a:r>
             <a:endParaRPr lang="en-US" sz="1400" dirty="0"/>
           </a:p>
@@ -9583,14 +10561,14 @@
       </p:sp>
       <p:sp>
         <p:nvSpPr>
-          <p:cNvPr id="9" name="Flat value"/>
+          <p:cNvPr id="9" name="VM note"/>
           <p:cNvSpPr txBox="1"/>
           <p:nvPr/>
         </p:nvSpPr>
         <p:spPr>
           <a:xfrm>
-            <a:off x="8915400" y="4754880"/>
-            <a:ext cx="2743200" cy="685800"/>
+            <a:off x="8686800" y="4846320"/>
+            <a:ext cx="2926080" cy="1097280"/>
           </a:xfrm>
           <a:prstGeom prst="rect">
             <a:avLst/>
@@ -9599,58 +10577,19 @@
           <a:ln/>
         </p:spPr>
         <p:txBody>
-          <a:bodyPr wrap="square" lIns="0" tIns="0" rIns="0" bIns="0" rtlCol="0" anchor="ctr"/>
+          <a:bodyPr wrap="square" lIns="0" tIns="0" rIns="0" bIns="0" rtlCol="0" anchor="t"/>
           <a:lstStyle/>
           <a:p>
             <a:pPr indent="0" marL="0">
               <a:buNone/>
             </a:pPr>
             <a:r>
-              <a:rPr lang="en-US" sz="4000" b="1" dirty="0">
-                <a:solidFill>
-                  <a:schemeClr val="accent1"/>
-                </a:solidFill>
-                <a:latin typeface="Cambria" pitchFamily="34" charset="0"/>
-                <a:ea typeface="Cambria" pitchFamily="34" charset="-122"/>
-                <a:cs typeface="Cambria" pitchFamily="34" charset="-120"/>
-              </a:rPr>
-              <a:t>512 GB</a:t>
-            </a:r>
-            <a:endParaRPr lang="en-US" sz="4000" dirty="0"/>
-          </a:p>
-        </p:txBody>
-      </p:sp>
-      <p:sp>
-        <p:nvSpPr>
-          <p:cNvPr id="10" name="Flat label"/>
-          <p:cNvSpPr txBox="1"/>
-          <p:nvPr/>
-        </p:nvSpPr>
-        <p:spPr>
-          <a:xfrm>
-            <a:off x="8915400" y="5468112"/>
-            <a:ext cx="2743200" cy="548640"/>
-          </a:xfrm>
-          <a:prstGeom prst="rect">
-            <a:avLst/>
-          </a:prstGeom>
-          <a:noFill/>
-          <a:ln/>
-        </p:spPr>
-        <p:txBody>
-          <a:bodyPr wrap="square" lIns="0" tIns="0" rIns="0" bIns="0" rtlCol="0" anchor="t"/>
-          <a:lstStyle/>
-          <a:p>
-            <a:pPr indent="0" marL="0">
-              <a:buNone/>
-            </a:pPr>
-            <a:r>
               <a:rPr lang="en-US" sz="1400" dirty="0">
                 <a:solidFill>
                   <a:schemeClr val="tx2"/>
                 </a:solidFill>
               </a:rPr>
-              <a:t>for a single flat table over the same address space</a:t>
+              <a:t>Why Hyper-V and cloud servers lean even harder on large pages and walk caches.</a:t>
             </a:r>
             <a:endParaRPr lang="en-US" sz="1400" dirty="0"/>
           </a:p>
@@ -9758,7 +10697,7 @@
                   <a:schemeClr val="accent1"/>
                 </a:solidFill>
               </a:rPr>
-              <a:t>HARDWARE SWITCHES</a:t>
+              <a:t>THE LIVE TREE</a:t>
             </a:r>
             <a:endParaRPr lang="en-US" sz="1300" dirty="0"/>
           </a:p>
@@ -9799,46 +10738,30 @@
                 <a:ea typeface="Cambria" pitchFamily="34" charset="-122"/>
                 <a:cs typeface="Cambria" pitchFamily="34" charset="-120"/>
               </a:rPr>
-              <a:t>The walk cache cuts page-table reads by 4x</a:t>
+              <a:t>Page tables exist only where memory is used</a:t>
             </a:r>
             <a:endParaRPr lang="en-US" sz="3200" dirty="0"/>
           </a:p>
         </p:txBody>
       </p:sp>
-      <p:graphicFrame>
-        <p:nvGraphicFramePr>
-          <p:cNvPr id="4" name="Reads chart" descr=""/>
-          <p:cNvGraphicFramePr/>
-          <p:nvPr/>
-        </p:nvGraphicFramePr>
-        <p:xfrm>
-          <a:off x="548640" y="1645920"/>
-          <a:ext cx="7863840" cy="4480560"/>
-        </p:xfrm>
-        <a:graphic xmlns:a="http://schemas.openxmlformats.org/drawingml/2006/main">
-          <a:graphicData uri="http://schemas.openxmlformats.org/drawingml/2006/chart">
-            <c:chart xmlns:c="http://schemas.openxmlformats.org/drawingml/2006/chart" r:id="rId1"/>
-          </a:graphicData>
-        </a:graphic>
-      </p:graphicFrame>
       <p:pic>
         <p:nvPicPr>
-          <p:cNvPr id="5" name="Hardware menu" descr="The Hardware menu with the switches">    </p:cNvPr>
+          <p:cNvPr id="4" name="tree.png" descr="The process's page-table tree after a few scenarios">    </p:cNvPr>
           <p:cNvPicPr>
             <a:picLocks noChangeAspect="1"/>
           </p:cNvPicPr>
           <p:nvPr/>
         </p:nvPicPr>
         <p:blipFill>
-          <a:blip r:embed="rId2"/>
+          <a:blip r:embed="rId1"/>
           <a:stretch>
             <a:fillRect/>
           </a:stretch>
         </p:blipFill>
         <p:spPr>
           <a:xfrm>
-            <a:off x="9052560" y="1737360"/>
-            <a:ext cx="2194560" cy="2411604"/>
+            <a:off x="548640" y="1645920"/>
+            <a:ext cx="7863840" cy="4262148"/>
           </a:xfrm>
           <a:prstGeom prst="rect">
             <a:avLst/>
@@ -9854,14 +10777,14 @@
       </p:pic>
       <p:sp>
         <p:nvSpPr>
-          <p:cNvPr id="6" name="Chart note"/>
+          <p:cNvPr id="5" name="Tables value"/>
           <p:cNvSpPr txBox="1"/>
           <p:nvPr/>
         </p:nvSpPr>
         <p:spPr>
           <a:xfrm>
-            <a:off x="8915400" y="4434840"/>
-            <a:ext cx="2697480" cy="1463040"/>
+            <a:off x="8915400" y="1828800"/>
+            <a:ext cx="2743200" cy="685800"/>
           </a:xfrm>
           <a:prstGeom prst="rect">
             <a:avLst/>
@@ -9870,6 +10793,45 @@
           <a:ln/>
         </p:spPr>
         <p:txBody>
+          <a:bodyPr wrap="square" lIns="0" tIns="0" rIns="0" bIns="0" rtlCol="0" anchor="ctr"/>
+          <a:lstStyle/>
+          <a:p>
+            <a:pPr indent="0" marL="0">
+              <a:buNone/>
+            </a:pPr>
+            <a:r>
+              <a:rPr lang="en-US" sz="4000" b="1" dirty="0">
+                <a:solidFill>
+                  <a:schemeClr val="accent2"/>
+                </a:solidFill>
+                <a:latin typeface="Cambria" pitchFamily="34" charset="0"/>
+                <a:ea typeface="Cambria" pitchFamily="34" charset="-122"/>
+                <a:cs typeface="Cambria" pitchFamily="34" charset="-120"/>
+              </a:rPr>
+              <a:t>8 tables</a:t>
+            </a:r>
+            <a:endParaRPr lang="en-US" sz="4000" dirty="0"/>
+          </a:p>
+        </p:txBody>
+      </p:sp>
+      <p:sp>
+        <p:nvSpPr>
+          <p:cNvPr id="6" name="Tables label"/>
+          <p:cNvSpPr txBox="1"/>
+          <p:nvPr/>
+        </p:nvSpPr>
+        <p:spPr>
+          <a:xfrm>
+            <a:off x="8915400" y="2542032"/>
+            <a:ext cx="2743200" cy="548640"/>
+          </a:xfrm>
+          <a:prstGeom prst="rect">
+            <a:avLst/>
+          </a:prstGeom>
+          <a:noFill/>
+          <a:ln/>
+        </p:spPr>
+        <p:txBody>
           <a:bodyPr wrap="square" lIns="0" tIns="0" rIns="0" bIns="0" rtlCol="0" anchor="t"/>
           <a:lstStyle/>
           <a:p>
@@ -9877,14 +10839,164 @@
               <a:buNone/>
             </a:pPr>
             <a:r>
-              <a:rPr lang="en-US" sz="1300" dirty="0">
+              <a:rPr lang="en-US" sz="1400" dirty="0">
                 <a:solidFill>
                   <a:schemeClr val="tx2"/>
                 </a:solidFill>
               </a:rPr>
-              <a:t>192 accesses: 64 heap pages written twice, plus 64 touches of the 4 MB buffer. Model output, not a hardware measurement.</a:t>
-            </a:r>
-            <a:endParaRPr lang="en-US" sz="1300" dirty="0"/>
+              <a:t>Level 4 to Level 1, built on demand</a:t>
+            </a:r>
+            <a:endParaRPr lang="en-US" sz="1400" dirty="0"/>
+          </a:p>
+        </p:txBody>
+      </p:sp>
+      <p:sp>
+        <p:nvSpPr>
+          <p:cNvPr id="7" name="Used value"/>
+          <p:cNvSpPr txBox="1"/>
+          <p:nvPr/>
+        </p:nvSpPr>
+        <p:spPr>
+          <a:xfrm>
+            <a:off x="8915400" y="3291840"/>
+            <a:ext cx="2743200" cy="685800"/>
+          </a:xfrm>
+          <a:prstGeom prst="rect">
+            <a:avLst/>
+          </a:prstGeom>
+          <a:noFill/>
+          <a:ln/>
+        </p:spPr>
+        <p:txBody>
+          <a:bodyPr wrap="square" lIns="0" tIns="0" rIns="0" bIns="0" rtlCol="0" anchor="ctr"/>
+          <a:lstStyle/>
+          <a:p>
+            <a:pPr indent="0" marL="0">
+              <a:buNone/>
+            </a:pPr>
+            <a:r>
+              <a:rPr lang="en-US" sz="4000" b="1" dirty="0">
+                <a:solidFill>
+                  <a:schemeClr val="accent3"/>
+                </a:solidFill>
+                <a:latin typeface="Cambria" pitchFamily="34" charset="0"/>
+                <a:ea typeface="Cambria" pitchFamily="34" charset="-122"/>
+                <a:cs typeface="Cambria" pitchFamily="34" charset="-120"/>
+              </a:rPr>
+              <a:t>32 KB</a:t>
+            </a:r>
+            <a:endParaRPr lang="en-US" sz="4000" dirty="0"/>
+          </a:p>
+        </p:txBody>
+      </p:sp>
+      <p:sp>
+        <p:nvSpPr>
+          <p:cNvPr id="8" name="Used label"/>
+          <p:cNvSpPr txBox="1"/>
+          <p:nvPr/>
+        </p:nvSpPr>
+        <p:spPr>
+          <a:xfrm>
+            <a:off x="8915400" y="4005072"/>
+            <a:ext cx="2743200" cy="548640"/>
+          </a:xfrm>
+          <a:prstGeom prst="rect">
+            <a:avLst/>
+          </a:prstGeom>
+          <a:noFill/>
+          <a:ln/>
+        </p:spPr>
+        <p:txBody>
+          <a:bodyPr wrap="square" lIns="0" tIns="0" rIns="0" bIns="0" rtlCol="0" anchor="t"/>
+          <a:lstStyle/>
+          <a:p>
+            <a:pPr indent="0" marL="0">
+              <a:buNone/>
+            </a:pPr>
+            <a:r>
+              <a:rPr lang="en-US" sz="1400" dirty="0">
+                <a:solidFill>
+                  <a:schemeClr val="tx2"/>
+                </a:solidFill>
+              </a:rPr>
+              <a:t>of page-table memory for this process</a:t>
+            </a:r>
+            <a:endParaRPr lang="en-US" sz="1400" dirty="0"/>
+          </a:p>
+        </p:txBody>
+      </p:sp>
+      <p:sp>
+        <p:nvSpPr>
+          <p:cNvPr id="9" name="Flat value"/>
+          <p:cNvSpPr txBox="1"/>
+          <p:nvPr/>
+        </p:nvSpPr>
+        <p:spPr>
+          <a:xfrm>
+            <a:off x="8915400" y="4754880"/>
+            <a:ext cx="2743200" cy="685800"/>
+          </a:xfrm>
+          <a:prstGeom prst="rect">
+            <a:avLst/>
+          </a:prstGeom>
+          <a:noFill/>
+          <a:ln/>
+        </p:spPr>
+        <p:txBody>
+          <a:bodyPr wrap="square" lIns="0" tIns="0" rIns="0" bIns="0" rtlCol="0" anchor="ctr"/>
+          <a:lstStyle/>
+          <a:p>
+            <a:pPr indent="0" marL="0">
+              <a:buNone/>
+            </a:pPr>
+            <a:r>
+              <a:rPr lang="en-US" sz="4000" b="1" dirty="0">
+                <a:solidFill>
+                  <a:schemeClr val="accent1"/>
+                </a:solidFill>
+                <a:latin typeface="Cambria" pitchFamily="34" charset="0"/>
+                <a:ea typeface="Cambria" pitchFamily="34" charset="-122"/>
+                <a:cs typeface="Cambria" pitchFamily="34" charset="-120"/>
+              </a:rPr>
+              <a:t>512 GB</a:t>
+            </a:r>
+            <a:endParaRPr lang="en-US" sz="4000" dirty="0"/>
+          </a:p>
+        </p:txBody>
+      </p:sp>
+      <p:sp>
+        <p:nvSpPr>
+          <p:cNvPr id="10" name="Flat label"/>
+          <p:cNvSpPr txBox="1"/>
+          <p:nvPr/>
+        </p:nvSpPr>
+        <p:spPr>
+          <a:xfrm>
+            <a:off x="8915400" y="5468112"/>
+            <a:ext cx="2743200" cy="548640"/>
+          </a:xfrm>
+          <a:prstGeom prst="rect">
+            <a:avLst/>
+          </a:prstGeom>
+          <a:noFill/>
+          <a:ln/>
+        </p:spPr>
+        <p:txBody>
+          <a:bodyPr wrap="square" lIns="0" tIns="0" rIns="0" bIns="0" rtlCol="0" anchor="t"/>
+          <a:lstStyle/>
+          <a:p>
+            <a:pPr indent="0" marL="0">
+              <a:buNone/>
+            </a:pPr>
+            <a:r>
+              <a:rPr lang="en-US" sz="1400" dirty="0">
+                <a:solidFill>
+                  <a:schemeClr val="tx2"/>
+                </a:solidFill>
+              </a:rPr>
+              <a:t>for a single flat table over the same address space</a:t>
+            </a:r>
+            <a:endParaRPr lang="en-US" sz="1400" dirty="0"/>
           </a:p>
         </p:txBody>
       </p:sp>

</xml_diff>

<commit_message>
Show full page tables and the physical address in the live tree
Each table now lists every used entry with the empty slots grouped into
ranges, instead of cutting off after six rows. Page entries show the
physical page they map, and the latest walk ends in a RAM box with the
final physical address.

Co-Authored-By: Claude Opus 5.5 <noreply@anthropic.com>
</commit_message>
<xml_diff>
--- a/deliverables/review3_changes.pptx
+++ b/deliverables/review3_changes.pptx
@@ -120,19 +120,19 @@
   <p:extLst>
     <p:ext uri="{521415D9-36F7-43E2-AB2F-B90AF26B5E84}">
       <p14:sectionLst xmlns:p14="http://schemas.microsoft.com/office/powerpoint/2010/main">
-        <p14:section name="Opening" id="{05b8fad7-a341-303e-058e-6843178fd647}">
+        <p14:section name="Opening" id="{cfa7763f-204b-71a0-45d2-d0f8053d3ed7}">
           <p14:sldIdLst>
             <p14:sldId id="256"/>
           </p14:sldIdLst>
         </p14:section>
-        <p14:section name="What we added" id="{580237b9-4be9-0c85-c185-5d945580eb96}">
+        <p14:section name="What we added" id="{0365839e-625d-bbd2-7939-3c2865fb18b7}">
           <p14:sldIdLst>
             <p14:sldId id="257"/>
             <p14:sldId id="258"/>
             <p14:sldId id="259"/>
           </p14:sldIdLst>
         </p14:section>
-        <p14:section name="The demo" id="{0d61c4a9-7b54-7efd-3b03-ed089c7d9ee2}">
+        <p14:section name="The demo" id="{d816c4e1-9baf-04a7-b96d-0634f1758bb3}">
           <p14:sldIdLst>
             <p14:sldId id="260"/>
             <p14:sldId id="261"/>
@@ -144,7 +144,7 @@
             <p14:sldId id="267"/>
           </p14:sldIdLst>
         </p14:section>
-        <p14:section name="Changes and next" id="{1cff947c-c767-cd7d-cc4f-f3be857eabea}">
+        <p14:section name="Changes and next" id="{efa65d35-78ae-91dc-6555-c5956e0f613b}">
           <p14:sldIdLst>
             <p14:sldId id="268"/>
             <p14:sldId id="269"/>
@@ -10761,7 +10761,7 @@
         <p:spPr>
           <a:xfrm>
             <a:off x="548640" y="1645920"/>
-            <a:ext cx="7863840" cy="4262148"/>
+            <a:ext cx="7854809" cy="4480560"/>
           </a:xfrm>
           <a:prstGeom prst="rect">
             <a:avLst/>
@@ -10844,7 +10844,7 @@
                   <a:schemeClr val="tx2"/>
                 </a:solidFill>
               </a:rPr>
-              <a:t>Level 4 to Level 1, built on demand</a:t>
+              <a:t>Level 4 to Level 1, built on demand; the walk ends at a physical address</a:t>
             </a:r>
             <a:endParaRPr lang="en-US" sz="1400" dirty="0"/>
           </a:p>

</xml_diff>